<commit_message>
Moved slides into 01-Python/slides folder
</commit_message>
<xml_diff>
--- a/04-Matplotlib/Slides/matplotlib_guide.pptx
+++ b/04-Matplotlib/Slides/matplotlib_guide.pptx
@@ -4,6 +4,9 @@
   <p:sldMasterIdLst>
     <p:sldMasterId id="2147483648" r:id="rId1"/>
   </p:sldMasterIdLst>
+  <p:notesMasterIdLst>
+    <p:notesMasterId r:id="rId15"/>
+  </p:notesMasterIdLst>
   <p:sldIdLst>
     <p:sldId id="256" r:id="rId2"/>
     <p:sldId id="257" r:id="rId3"/>
@@ -19,10 +22,7 @@
     <p:sldId id="267" r:id="rId13"/>
     <p:sldId id="268" r:id="rId14"/>
   </p:sldIdLst>
-  <p:notesMasterIdLst>
-    <p:notesMasterId r:id="rId15"/>
-  </p:notesMasterIdLst>
-  <p:sldSz cx="9144000" cy="5143500"/>
+  <p:sldSz cx="9144000" cy="5143500" type="screen16x9"/>
   <p:notesSz cx="5143500" cy="9144000"/>
   <p:defaultTextStyle>
     <a:lvl1pPr marL="0" algn="l" defTabSz="914400" rtl="0" eaLnBrk="1" latinLnBrk="0" hangingPunct="1">
@@ -116,6 +116,11 @@
       </a:defRPr>
     </a:lvl9pPr>
   </p:defaultTextStyle>
+  <p:extLst>
+    <p:ext uri="{EFAFB233-063F-42B5-8137-9DF3F51BA10A}">
+      <p15:sldGuideLst xmlns:p15="http://schemas.microsoft.com/office/powerpoint/2012/main"/>
+    </p:ext>
+  </p:extLst>
 </p:presentation>
 </file>
 
@@ -141,234 +146,10 @@
           <a:chExt cx="0" cy="0"/>
         </a:xfrm>
       </p:grpSpPr>
-      <p:sp>
-        <p:nvSpPr>
-          <p:cNvPr id="2" name="Header Placeholder 1"/>
-          <p:cNvSpPr>
-            <a:spLocks noGrp="1"/>
-          </p:cNvSpPr>
-          <p:nvPr>
-            <p:ph type="hdr" sz="quarter"/>
-          </p:nvPr>
-        </p:nvSpPr>
-        <p:spPr>
-          <a:xfrm>
-            <a:off x="0" y="0"/>
-            <a:ext cx="2971800" cy="458788"/>
-          </a:xfrm>
-          <a:prstGeom prst="rect">
-            <a:avLst/>
-          </a:prstGeom>
-        </p:spPr>
-        <p:txBody>
-          <a:bodyPr vert="horz" lIns="91440" tIns="45720" rIns="91440" bIns="45720" rtlCol="0"/>
-          <a:lstStyle>
-            <a:lvl1pPr algn="l">
-              <a:defRPr sz="1200"/>
-            </a:lvl1pPr>
-          </a:lstStyle>
-          <a:p>
-            <a:endParaRPr lang="en-US"/>
-          </a:p>
-        </p:txBody>
-      </p:sp>
-      <p:sp>
-        <p:nvSpPr>
-          <p:cNvPr id="3" name="Date Placeholder 2"/>
-          <p:cNvSpPr>
-            <a:spLocks noGrp="1"/>
-          </p:cNvSpPr>
-          <p:nvPr>
-            <p:ph type="dt" idx="1"/>
-          </p:nvPr>
-        </p:nvSpPr>
-        <p:spPr>
-          <a:xfrm>
-            <a:off x="3884613" y="0"/>
-            <a:ext cx="2971800" cy="458788"/>
-          </a:xfrm>
-          <a:prstGeom prst="rect">
-            <a:avLst/>
-          </a:prstGeom>
-        </p:spPr>
-        <p:txBody>
-          <a:bodyPr vert="horz" lIns="91440" tIns="45720" rIns="91440" bIns="45720" rtlCol="0"/>
-          <a:lstStyle>
-            <a:lvl1pPr algn="r">
-              <a:defRPr sz="1200"/>
-            </a:lvl1pPr>
-          </a:lstStyle>
-          <a:p>
-            <a:fld id="{5282F153-3F37-0F45-9E97-73ACFA13230C}" type="datetimeFigureOut">
-              <a:rPr lang="en-US"/>
-              <a:t>7/23/19</a:t>
-            </a:fld>
-            <a:endParaRPr lang="en-US"/>
-          </a:p>
-        </p:txBody>
-      </p:sp>
-      <p:sp>
-        <p:nvSpPr>
-          <p:cNvPr id="4" name="Slide Image Placeholder 3"/>
-          <p:cNvSpPr>
-            <a:spLocks noGrp="1" noRot="1" noChangeAspect="1"/>
-          </p:cNvSpPr>
-          <p:nvPr>
-            <p:ph type="sldImg" idx="2"/>
-          </p:nvPr>
-        </p:nvSpPr>
-        <p:spPr>
-          <a:xfrm>
-            <a:off x="685800" y="1143000"/>
-            <a:ext cx="5486400" cy="3086100"/>
-          </a:xfrm>
-          <a:prstGeom prst="rect">
-            <a:avLst/>
-          </a:prstGeom>
-          <a:noFill/>
-          <a:ln w="12700">
-            <a:solidFill>
-              <a:prstClr val="black"/>
-            </a:solidFill>
-          </a:ln>
-        </p:spPr>
-        <p:txBody>
-          <a:bodyPr vert="horz" lIns="91440" tIns="45720" rIns="91440" bIns="45720" rtlCol="0" anchor="ctr"/>
-          <a:lstStyle/>
-          <a:p>
-            <a:endParaRPr lang="en-US"/>
-          </a:p>
-        </p:txBody>
-      </p:sp>
-      <p:sp>
-        <p:nvSpPr>
-          <p:cNvPr id="5" name="Notes Placeholder 4"/>
-          <p:cNvSpPr>
-            <a:spLocks noGrp="1"/>
-          </p:cNvSpPr>
-          <p:nvPr>
-            <p:ph type="body" sz="quarter" idx="3"/>
-          </p:nvPr>
-        </p:nvSpPr>
-        <p:spPr>
-          <a:xfrm>
-            <a:off x="685800" y="4400550"/>
-            <a:ext cx="5486400" cy="3600450"/>
-          </a:xfrm>
-          <a:prstGeom prst="rect">
-            <a:avLst/>
-          </a:prstGeom>
-        </p:spPr>
-        <p:txBody>
-          <a:bodyPr vert="horz" lIns="91440" tIns="45720" rIns="91440" bIns="45720" rtlCol="0"/>
-          <a:lstStyle/>
-          <a:p>
-            <a:pPr lvl="0"/>
-            <a:r>
-              <a:rPr lang="en-US"/>
-              <a:t>Click to edit Master text styles</a:t>
-            </a:r>
-          </a:p>
-          <a:p>
-            <a:pPr lvl="1"/>
-            <a:r>
-              <a:rPr lang="en-US"/>
-              <a:t>Second level</a:t>
-            </a:r>
-          </a:p>
-          <a:p>
-            <a:pPr lvl="2"/>
-            <a:r>
-              <a:rPr lang="en-US"/>
-              <a:t>Third level</a:t>
-            </a:r>
-          </a:p>
-          <a:p>
-            <a:pPr lvl="3"/>
-            <a:r>
-              <a:rPr lang="en-US"/>
-              <a:t>Fourth level</a:t>
-            </a:r>
-          </a:p>
-          <a:p>
-            <a:pPr lvl="4"/>
-            <a:r>
-              <a:rPr lang="en-US"/>
-              <a:t>Fifth level</a:t>
-            </a:r>
-          </a:p>
-        </p:txBody>
-      </p:sp>
-      <p:sp>
-        <p:nvSpPr>
-          <p:cNvPr id="6" name="Footer Placeholder 5"/>
-          <p:cNvSpPr>
-            <a:spLocks noGrp="1"/>
-          </p:cNvSpPr>
-          <p:nvPr>
-            <p:ph type="ftr" sz="quarter" idx="4"/>
-          </p:nvPr>
-        </p:nvSpPr>
-        <p:spPr>
-          <a:xfrm>
-            <a:off x="0" y="8685213"/>
-            <a:ext cx="2971800" cy="458787"/>
-          </a:xfrm>
-          <a:prstGeom prst="rect">
-            <a:avLst/>
-          </a:prstGeom>
-        </p:spPr>
-        <p:txBody>
-          <a:bodyPr vert="horz" lIns="91440" tIns="45720" rIns="91440" bIns="45720" rtlCol="0" anchor="b"/>
-          <a:lstStyle>
-            <a:lvl1pPr algn="l">
-              <a:defRPr sz="1200"/>
-            </a:lvl1pPr>
-          </a:lstStyle>
-          <a:p>
-            <a:endParaRPr lang="en-US"/>
-          </a:p>
-        </p:txBody>
-      </p:sp>
-      <p:sp>
-        <p:nvSpPr>
-          <p:cNvPr id="7" name="Slide Number Placeholder 6"/>
-          <p:cNvSpPr>
-            <a:spLocks noGrp="1"/>
-          </p:cNvSpPr>
-          <p:nvPr>
-            <p:ph type="sldNum" sz="quarter" idx="5"/>
-          </p:nvPr>
-        </p:nvSpPr>
-        <p:spPr>
-          <a:xfrm>
-            <a:off x="3884613" y="8685213"/>
-            <a:ext cx="2971800" cy="458787"/>
-          </a:xfrm>
-          <a:prstGeom prst="rect">
-            <a:avLst/>
-          </a:prstGeom>
-        </p:spPr>
-        <p:txBody>
-          <a:bodyPr vert="horz" lIns="91440" tIns="45720" rIns="91440" bIns="45720" rtlCol="0" anchor="b"/>
-          <a:lstStyle>
-            <a:lvl1pPr algn="r">
-              <a:defRPr sz="1200"/>
-            </a:lvl1pPr>
-          </a:lstStyle>
-          <a:p>
-            <a:fld id="{CE5E9CC1-C706-0F49-92D6-E571CC5EEA8F}" type="slidenum">
-              <a:rPr lang="en-US"/>
-              <a:t>‹#›</a:t>
-            </a:fld>
-            <a:endParaRPr lang="en-US"/>
-          </a:p>
-        </p:txBody>
-      </p:sp>
     </p:spTree>
     <p:extLst>
       <p:ext uri="{BB962C8B-B14F-4D97-AF65-F5344CB8AC3E}">
-        <p14:creationId xmlns:p14="http://schemas.microsoft.com/office/powerpoint/2010/main" val="1024086991"/>
+        <p14:creationId xmlns:p14="http://schemas.microsoft.com/office/powerpoint/2010/main" val="813738984"/>
       </p:ext>
     </p:extLst>
   </p:cSld>
@@ -512,10 +293,6 @@
           <a:bodyPr/>
           <a:lstStyle/>
           <a:p>
-            <a:r>
-              <a:rPr lang="en-US" dirty="0"/>
-              <a:t/>
-            </a:r>
             <a:endParaRPr lang="en-US" dirty="0"/>
           </a:p>
         </p:txBody>
@@ -600,10 +377,6 @@
           <a:bodyPr/>
           <a:lstStyle/>
           <a:p>
-            <a:r>
-              <a:rPr lang="en-US" dirty="0"/>
-              <a:t/>
-            </a:r>
             <a:endParaRPr lang="en-US" dirty="0"/>
           </a:p>
         </p:txBody>
@@ -688,10 +461,6 @@
           <a:bodyPr/>
           <a:lstStyle/>
           <a:p>
-            <a:r>
-              <a:rPr lang="en-US" dirty="0"/>
-              <a:t/>
-            </a:r>
             <a:endParaRPr lang="en-US" dirty="0"/>
           </a:p>
         </p:txBody>
@@ -776,10 +545,6 @@
           <a:bodyPr/>
           <a:lstStyle/>
           <a:p>
-            <a:r>
-              <a:rPr lang="en-US" dirty="0"/>
-              <a:t/>
-            </a:r>
             <a:endParaRPr lang="en-US" dirty="0"/>
           </a:p>
         </p:txBody>
@@ -864,10 +629,6 @@
           <a:bodyPr/>
           <a:lstStyle/>
           <a:p>
-            <a:r>
-              <a:rPr lang="en-US" dirty="0"/>
-              <a:t/>
-            </a:r>
             <a:endParaRPr lang="en-US" dirty="0"/>
           </a:p>
         </p:txBody>
@@ -952,10 +713,6 @@
           <a:bodyPr/>
           <a:lstStyle/>
           <a:p>
-            <a:r>
-              <a:rPr lang="en-US" dirty="0"/>
-              <a:t/>
-            </a:r>
             <a:endParaRPr lang="en-US" dirty="0"/>
           </a:p>
         </p:txBody>
@@ -1040,10 +797,6 @@
           <a:bodyPr/>
           <a:lstStyle/>
           <a:p>
-            <a:r>
-              <a:rPr lang="en-US" dirty="0"/>
-              <a:t/>
-            </a:r>
             <a:endParaRPr lang="en-US" dirty="0"/>
           </a:p>
         </p:txBody>
@@ -1128,10 +881,6 @@
           <a:bodyPr/>
           <a:lstStyle/>
           <a:p>
-            <a:r>
-              <a:rPr lang="en-US" dirty="0"/>
-              <a:t/>
-            </a:r>
             <a:endParaRPr lang="en-US" dirty="0"/>
           </a:p>
         </p:txBody>
@@ -1216,10 +965,6 @@
           <a:bodyPr/>
           <a:lstStyle/>
           <a:p>
-            <a:r>
-              <a:rPr lang="en-US" dirty="0"/>
-              <a:t/>
-            </a:r>
             <a:endParaRPr lang="en-US" dirty="0"/>
           </a:p>
         </p:txBody>
@@ -1304,10 +1049,6 @@
           <a:bodyPr/>
           <a:lstStyle/>
           <a:p>
-            <a:r>
-              <a:rPr lang="en-US" dirty="0"/>
-              <a:t/>
-            </a:r>
             <a:endParaRPr lang="en-US" dirty="0"/>
           </a:p>
         </p:txBody>
@@ -1392,10 +1133,6 @@
           <a:bodyPr/>
           <a:lstStyle/>
           <a:p>
-            <a:r>
-              <a:rPr lang="en-US" dirty="0"/>
-              <a:t/>
-            </a:r>
             <a:endParaRPr lang="en-US" dirty="0"/>
           </a:p>
         </p:txBody>
@@ -1480,10 +1217,6 @@
           <a:bodyPr/>
           <a:lstStyle/>
           <a:p>
-            <a:r>
-              <a:rPr lang="en-US" dirty="0"/>
-              <a:t/>
-            </a:r>
             <a:endParaRPr lang="en-US" dirty="0"/>
           </a:p>
         </p:txBody>
@@ -1568,10 +1301,6 @@
           <a:bodyPr/>
           <a:lstStyle/>
           <a:p>
-            <a:r>
-              <a:rPr lang="en-US" dirty="0"/>
-              <a:t/>
-            </a:r>
             <a:endParaRPr lang="en-US" dirty="0"/>
           </a:p>
         </p:txBody>
@@ -1645,6 +1374,11 @@
 <file path=ppt/slideMasters/slideMaster1.xml><?xml version="1.0" encoding="utf-8"?>
 <p:sldMaster xmlns:a="http://schemas.openxmlformats.org/drawingml/2006/main" xmlns:r="http://schemas.openxmlformats.org/officeDocument/2006/relationships" xmlns:p="http://schemas.openxmlformats.org/presentationml/2006/main">
   <p:cSld>
+    <p:bg>
+      <p:bgRef idx="1001">
+        <a:schemeClr val="bg1"/>
+      </p:bgRef>
+    </p:bg>
     <p:spTree>
       <p:nvGrpSpPr>
         <p:cNvPr id="1" name=""/>
@@ -1927,6 +1661,7 @@
         <a:solidFill>
           <a:srgbClr val="0D1B2A"/>
         </a:solidFill>
+        <a:effectLst/>
       </p:bgPr>
     </p:bg>
     <p:spTree>
@@ -2149,7 +1884,7 @@
           <a:bodyPr wrap="square" lIns="0" tIns="0" rIns="0" bIns="0" rtlCol="0" anchor="ctr"/>
           <a:lstStyle/>
           <a:p>
-            <a:pPr indent="0" marL="0">
+            <a:pPr marL="0" indent="0">
               <a:buNone/>
             </a:pPr>
             <a:r>
@@ -2188,7 +1923,7 @@
           <a:bodyPr wrap="square" lIns="0" tIns="0" rIns="0" bIns="0" rtlCol="0" anchor="ctr"/>
           <a:lstStyle/>
           <a:p>
-            <a:pPr indent="0" marL="0">
+            <a:pPr marL="0" indent="0">
               <a:buNone/>
             </a:pPr>
             <a:r>
@@ -2227,7 +1962,7 @@
           <a:bodyPr wrap="square" lIns="0" tIns="0" rIns="0" bIns="0" rtlCol="0" anchor="ctr"/>
           <a:lstStyle/>
           <a:p>
-            <a:pPr indent="0" marL="0">
+            <a:pPr marL="0" indent="0">
               <a:buNone/>
             </a:pPr>
             <a:r>
@@ -2293,7 +2028,7 @@
           <a:bodyPr wrap="square" rtlCol="0" anchor="ctr"/>
           <a:lstStyle/>
           <a:p>
-            <a:pPr algn="ctr" indent="0" marL="0">
+            <a:pPr marL="0" indent="0" algn="ctr">
               <a:buNone/>
             </a:pPr>
             <a:r>
@@ -2313,13 +2048,13 @@
       </p:sp>
       <p:sp>
         <p:nvSpPr>
-          <p:cNvPr id="15" name="Shape 13"/>
-          <p:cNvSpPr/>
-          <p:nvPr/>
-        </p:nvSpPr>
-        <p:spPr>
-          <a:xfrm>
-            <a:off x="2743200" y="3108960"/>
+          <p:cNvPr id="17" name="Shape 15"/>
+          <p:cNvSpPr/>
+          <p:nvPr/>
+        </p:nvSpPr>
+        <p:spPr>
+          <a:xfrm>
+            <a:off x="2743200" y="3063240"/>
             <a:ext cx="2011680" cy="457200"/>
           </a:xfrm>
           <a:prstGeom prst="roundRect">
@@ -2340,13 +2075,13 @@
       </p:sp>
       <p:sp>
         <p:nvSpPr>
-          <p:cNvPr id="16" name="Text 14"/>
-          <p:cNvSpPr/>
-          <p:nvPr/>
-        </p:nvSpPr>
-        <p:spPr>
-          <a:xfrm>
-            <a:off x="2743200" y="3108960"/>
+          <p:cNvPr id="18" name="Text 16"/>
+          <p:cNvSpPr/>
+          <p:nvPr/>
+        </p:nvSpPr>
+        <p:spPr>
+          <a:xfrm>
+            <a:off x="2743200" y="3076956"/>
             <a:ext cx="2011680" cy="457200"/>
           </a:xfrm>
           <a:prstGeom prst="rect">
@@ -2359,7 +2094,7 @@
           <a:bodyPr wrap="square" rtlCol="0" anchor="ctr"/>
           <a:lstStyle/>
           <a:p>
-            <a:pPr algn="ctr" indent="0" marL="0">
+            <a:pPr marL="0" indent="0" algn="ctr">
               <a:buNone/>
             </a:pPr>
             <a:r>
@@ -2371,7 +2106,7 @@
                 <a:ea typeface="Calibri" pitchFamily="34" charset="-122"/>
                 <a:cs typeface="Calibri" pitchFamily="34" charset="-120"/>
               </a:rPr>
-              <a:t>⏰  4 Hours</a:t>
+              <a:t>🐍  Python</a:t>
             </a:r>
             <a:endParaRPr lang="en-US" sz="1300" dirty="0"/>
           </a:p>
@@ -2379,73 +2114,7 @@
       </p:sp>
       <p:sp>
         <p:nvSpPr>
-          <p:cNvPr id="17" name="Shape 15"/>
-          <p:cNvSpPr/>
-          <p:nvPr/>
-        </p:nvSpPr>
-        <p:spPr>
-          <a:xfrm>
-            <a:off x="5029200" y="3108960"/>
-            <a:ext cx="2011680" cy="457200"/>
-          </a:xfrm>
-          <a:prstGeom prst="roundRect">
-            <a:avLst>
-              <a:gd name="adj" fmla="val 16000"/>
-            </a:avLst>
-          </a:prstGeom>
-          <a:solidFill>
-            <a:srgbClr val="1A2E42"/>
-          </a:solidFill>
-          <a:ln w="19050">
-            <a:solidFill>
-              <a:srgbClr val="FF6B35"/>
-            </a:solidFill>
-            <a:prstDash val="solid"/>
-          </a:ln>
-        </p:spPr>
-      </p:sp>
-      <p:sp>
-        <p:nvSpPr>
-          <p:cNvPr id="18" name="Text 16"/>
-          <p:cNvSpPr/>
-          <p:nvPr/>
-        </p:nvSpPr>
-        <p:spPr>
-          <a:xfrm>
-            <a:off x="5029200" y="3108960"/>
-            <a:ext cx="2011680" cy="457200"/>
-          </a:xfrm>
-          <a:prstGeom prst="rect">
-            <a:avLst/>
-          </a:prstGeom>
-          <a:noFill/>
-          <a:ln/>
-        </p:spPr>
-        <p:txBody>
-          <a:bodyPr wrap="square" rtlCol="0" anchor="ctr"/>
-          <a:lstStyle/>
-          <a:p>
-            <a:pPr algn="ctr" indent="0" marL="0">
-              <a:buNone/>
-            </a:pPr>
-            <a:r>
-              <a:rPr lang="en-US" sz="1300" dirty="0">
-                <a:solidFill>
-                  <a:srgbClr val="FFFFFF"/>
-                </a:solidFill>
-                <a:latin typeface="Calibri" pitchFamily="34" charset="0"/>
-                <a:ea typeface="Calibri" pitchFamily="34" charset="-122"/>
-                <a:cs typeface="Calibri" pitchFamily="34" charset="-120"/>
-              </a:rPr>
-              <a:t>🐍  Python</a:t>
-            </a:r>
-            <a:endParaRPr lang="en-US" sz="1300" dirty="0"/>
-          </a:p>
-        </p:txBody>
-      </p:sp>
-      <p:sp>
-        <p:nvSpPr>
-          <p:cNvPr id="19" name="Shape 17"/>
+          <p:cNvPr id="20" name="Text 18"/>
           <p:cNvSpPr/>
           <p:nvPr/>
         </p:nvSpPr>
@@ -2457,31 +2126,6 @@
           <a:prstGeom prst="rect">
             <a:avLst/>
           </a:prstGeom>
-          <a:solidFill>
-            <a:srgbClr val="00B4D8"/>
-          </a:solidFill>
-          <a:ln w="12700">
-            <a:solidFill>
-              <a:srgbClr val="00B4D8"/>
-            </a:solidFill>
-            <a:prstDash val="solid"/>
-          </a:ln>
-        </p:spPr>
-      </p:sp>
-      <p:sp>
-        <p:nvSpPr>
-          <p:cNvPr id="20" name="Text 18"/>
-          <p:cNvSpPr/>
-          <p:nvPr/>
-        </p:nvSpPr>
-        <p:spPr>
-          <a:xfrm>
-            <a:off x="457200" y="4160520"/>
-            <a:ext cx="1920240" cy="594360"/>
-          </a:xfrm>
-          <a:prstGeom prst="rect">
-            <a:avLst/>
-          </a:prstGeom>
           <a:noFill/>
           <a:ln/>
         </p:spPr>
@@ -2489,7 +2133,7 @@
           <a:bodyPr wrap="square" rtlCol="0" anchor="ctr"/>
           <a:lstStyle/>
           <a:p>
-            <a:pPr algn="ctr" indent="0" marL="0">
+            <a:pPr marL="0" indent="0" algn="ctr">
               <a:buNone/>
             </a:pPr>
             <a:r>
@@ -2509,7 +2153,7 @@
       </p:sp>
       <p:sp>
         <p:nvSpPr>
-          <p:cNvPr id="21" name="Shape 19"/>
+          <p:cNvPr id="22" name="Text 20"/>
           <p:cNvSpPr/>
           <p:nvPr/>
         </p:nvSpPr>
@@ -2521,31 +2165,6 @@
           <a:prstGeom prst="rect">
             <a:avLst/>
           </a:prstGeom>
-          <a:solidFill>
-            <a:srgbClr val="FF6B35"/>
-          </a:solidFill>
-          <a:ln w="12700">
-            <a:solidFill>
-              <a:srgbClr val="FF6B35"/>
-            </a:solidFill>
-            <a:prstDash val="solid"/>
-          </a:ln>
-        </p:spPr>
-      </p:sp>
-      <p:sp>
-        <p:nvSpPr>
-          <p:cNvPr id="22" name="Text 20"/>
-          <p:cNvSpPr/>
-          <p:nvPr/>
-        </p:nvSpPr>
-        <p:spPr>
-          <a:xfrm>
-            <a:off x="2651760" y="4160520"/>
-            <a:ext cx="1920240" cy="594360"/>
-          </a:xfrm>
-          <a:prstGeom prst="rect">
-            <a:avLst/>
-          </a:prstGeom>
           <a:noFill/>
           <a:ln/>
         </p:spPr>
@@ -2553,7 +2172,7 @@
           <a:bodyPr wrap="square" rtlCol="0" anchor="ctr"/>
           <a:lstStyle/>
           <a:p>
-            <a:pPr algn="ctr" indent="0" marL="0">
+            <a:pPr marL="0" indent="0" algn="ctr">
               <a:buNone/>
             </a:pPr>
             <a:r>
@@ -2565,7 +2184,7 @@
                 <a:ea typeface="Calibri" pitchFamily="34" charset="-122"/>
                 <a:cs typeface="Calibri" pitchFamily="34" charset="-120"/>
               </a:rPr>
-              <a:t>Hour 2: Intermediate</a:t>
+              <a:t>Hour Intermediate</a:t>
             </a:r>
             <a:endParaRPr lang="en-US" sz="1100" dirty="0"/>
           </a:p>
@@ -2573,7 +2192,7 @@
       </p:sp>
       <p:sp>
         <p:nvSpPr>
-          <p:cNvPr id="23" name="Shape 21"/>
+          <p:cNvPr id="24" name="Text 22"/>
           <p:cNvSpPr/>
           <p:nvPr/>
         </p:nvSpPr>
@@ -2585,31 +2204,6 @@
           <a:prstGeom prst="rect">
             <a:avLst/>
           </a:prstGeom>
-          <a:solidFill>
-            <a:srgbClr val="2EC4B6"/>
-          </a:solidFill>
-          <a:ln w="12700">
-            <a:solidFill>
-              <a:srgbClr val="2EC4B6"/>
-            </a:solidFill>
-            <a:prstDash val="solid"/>
-          </a:ln>
-        </p:spPr>
-      </p:sp>
-      <p:sp>
-        <p:nvSpPr>
-          <p:cNvPr id="24" name="Text 22"/>
-          <p:cNvSpPr/>
-          <p:nvPr/>
-        </p:nvSpPr>
-        <p:spPr>
-          <a:xfrm>
-            <a:off x="4846320" y="4160520"/>
-            <a:ext cx="1920240" cy="594360"/>
-          </a:xfrm>
-          <a:prstGeom prst="rect">
-            <a:avLst/>
-          </a:prstGeom>
           <a:noFill/>
           <a:ln/>
         </p:spPr>
@@ -2617,7 +2211,7 @@
           <a:bodyPr wrap="square" rtlCol="0" anchor="ctr"/>
           <a:lstStyle/>
           <a:p>
-            <a:pPr algn="ctr" indent="0" marL="0">
+            <a:pPr marL="0" indent="0" algn="ctr">
               <a:buNone/>
             </a:pPr>
             <a:r>
@@ -2637,7 +2231,7 @@
       </p:sp>
       <p:sp>
         <p:nvSpPr>
-          <p:cNvPr id="25" name="Shape 23"/>
+          <p:cNvPr id="26" name="Text 24"/>
           <p:cNvSpPr/>
           <p:nvPr/>
         </p:nvSpPr>
@@ -2649,31 +2243,6 @@
           <a:prstGeom prst="rect">
             <a:avLst/>
           </a:prstGeom>
-          <a:solidFill>
-            <a:srgbClr val="9B5DE5"/>
-          </a:solidFill>
-          <a:ln w="12700">
-            <a:solidFill>
-              <a:srgbClr val="9B5DE5"/>
-            </a:solidFill>
-            <a:prstDash val="solid"/>
-          </a:ln>
-        </p:spPr>
-      </p:sp>
-      <p:sp>
-        <p:nvSpPr>
-          <p:cNvPr id="26" name="Text 24"/>
-          <p:cNvSpPr/>
-          <p:nvPr/>
-        </p:nvSpPr>
-        <p:spPr>
-          <a:xfrm>
-            <a:off x="7040880" y="4160520"/>
-            <a:ext cx="1920240" cy="594360"/>
-          </a:xfrm>
-          <a:prstGeom prst="rect">
-            <a:avLst/>
-          </a:prstGeom>
           <a:noFill/>
           <a:ln/>
         </p:spPr>
@@ -2681,7 +2250,7 @@
           <a:bodyPr wrap="square" rtlCol="0" anchor="ctr"/>
           <a:lstStyle/>
           <a:p>
-            <a:pPr algn="ctr" indent="0" marL="0">
+            <a:pPr marL="0" indent="0" algn="ctr">
               <a:buNone/>
             </a:pPr>
             <a:r>
@@ -2696,6 +2265,119 @@
               <a:t>Hour 4: Advanced</a:t>
             </a:r>
             <a:endParaRPr lang="en-US" sz="1100" dirty="0"/>
+          </a:p>
+        </p:txBody>
+      </p:sp>
+      <p:sp>
+        <p:nvSpPr>
+          <p:cNvPr id="28" name="TextBox 27">
+            <a:extLst>
+              <a:ext uri="{FF2B5EF4-FFF2-40B4-BE49-F238E27FC236}">
+                <a16:creationId xmlns:a16="http://schemas.microsoft.com/office/drawing/2014/main" id="{3A511A25-8253-6241-FD21-DC5C767D6E73}"/>
+              </a:ext>
+            </a:extLst>
+          </p:cNvPr>
+          <p:cNvSpPr txBox="1"/>
+          <p:nvPr/>
+        </p:nvSpPr>
+        <p:spPr>
+          <a:xfrm>
+            <a:off x="457200" y="3724156"/>
+            <a:ext cx="4572000" cy="369332"/>
+          </a:xfrm>
+          <a:prstGeom prst="rect">
+            <a:avLst/>
+          </a:prstGeom>
+          <a:noFill/>
+        </p:spPr>
+        <p:txBody>
+          <a:bodyPr wrap="square">
+            <a:spAutoFit/>
+          </a:bodyPr>
+          <a:lstStyle/>
+          <a:p>
+            <a:pPr marL="0" indent="0">
+              <a:buNone/>
+            </a:pPr>
+            <a:r>
+              <a:rPr lang="en-US" sz="1800" dirty="0">
+                <a:solidFill>
+                  <a:srgbClr val="64748B"/>
+                </a:solidFill>
+                <a:latin typeface="Calibri" pitchFamily="34" charset="0"/>
+                <a:ea typeface="Calibri" pitchFamily="34" charset="-122"/>
+                <a:cs typeface="Calibri" pitchFamily="34" charset="-120"/>
+              </a:rPr>
+              <a:t>Research Assistant: </a:t>
+            </a:r>
+            <a:r>
+              <a:rPr lang="en-US" sz="1800" b="1" dirty="0">
+                <a:solidFill>
+                  <a:srgbClr val="FFFFFF"/>
+                </a:solidFill>
+                <a:latin typeface="Calibri" pitchFamily="34" charset="0"/>
+                <a:ea typeface="Calibri" pitchFamily="34" charset="-122"/>
+                <a:cs typeface="Calibri" pitchFamily="34" charset="-120"/>
+              </a:rPr>
+              <a:t>Muhammad Huzifa</a:t>
+            </a:r>
+            <a:endParaRPr lang="en-US" sz="1800" dirty="0"/>
+          </a:p>
+        </p:txBody>
+      </p:sp>
+      <p:sp>
+        <p:nvSpPr>
+          <p:cNvPr id="29" name="Text 9">
+            <a:extLst>
+              <a:ext uri="{FF2B5EF4-FFF2-40B4-BE49-F238E27FC236}">
+                <a16:creationId xmlns:a16="http://schemas.microsoft.com/office/drawing/2014/main" id="{40E65864-76C1-67DF-3917-3C391F1E430C}"/>
+              </a:ext>
+            </a:extLst>
+          </p:cNvPr>
+          <p:cNvSpPr/>
+          <p:nvPr/>
+        </p:nvSpPr>
+        <p:spPr>
+          <a:xfrm>
+            <a:off x="457200" y="4110252"/>
+            <a:ext cx="6400800" cy="347472"/>
+          </a:xfrm>
+          <a:prstGeom prst="rect">
+            <a:avLst/>
+          </a:prstGeom>
+          <a:noFill/>
+          <a:ln/>
+        </p:spPr>
+        <p:txBody>
+          <a:bodyPr wrap="square" rtlCol="0" anchor="ctr"/>
+          <a:lstStyle/>
+          <a:p>
+            <a:pPr marL="0" indent="0">
+              <a:buNone/>
+            </a:pPr>
+            <a:r>
+              <a:rPr lang="en-US" sz="1400" dirty="0">
+                <a:solidFill>
+                  <a:srgbClr val="64748B"/>
+                </a:solidFill>
+                <a:latin typeface="Calibri" pitchFamily="34" charset="0"/>
+                <a:ea typeface="Calibri" pitchFamily="34" charset="-122"/>
+                <a:cs typeface="Calibri" pitchFamily="34" charset="-120"/>
+              </a:rPr>
+              <a:t>Supervisor: </a:t>
+            </a:r>
+            <a:r>
+              <a:rPr lang="en-US" sz="1400" b="1" dirty="0">
+                <a:solidFill>
+                  <a:srgbClr val="FFFFFF"/>
+                </a:solidFill>
+                <a:latin typeface="Calibri" pitchFamily="34" charset="0"/>
+                <a:ea typeface="Calibri" pitchFamily="34" charset="-122"/>
+                <a:cs typeface="Calibri" pitchFamily="34" charset="-120"/>
+              </a:rPr>
+              <a:t>Dr. Muhammad Sajjad</a:t>
+            </a:r>
+            <a:endParaRPr lang="en-US" sz="1400" dirty="0"/>
           </a:p>
         </p:txBody>
       </p:sp>
@@ -2715,6 +2397,7 @@
         <a:solidFill>
           <a:srgbClr val="0D1B2A"/>
         </a:solidFill>
+        <a:effectLst/>
       </p:bgPr>
     </p:bg>
     <p:spTree>
@@ -2792,7 +2475,7 @@
           <a:bodyPr wrap="square" lIns="0" tIns="0" rIns="0" bIns="0" rtlCol="0" anchor="ctr"/>
           <a:lstStyle/>
           <a:p>
-            <a:pPr indent="0" marL="0">
+            <a:pPr marL="0" indent="0">
               <a:buNone/>
             </a:pPr>
             <a:r>
@@ -2831,7 +2514,7 @@
           <a:bodyPr wrap="square" lIns="0" tIns="0" rIns="0" bIns="0" rtlCol="0" anchor="ctr"/>
           <a:lstStyle/>
           <a:p>
-            <a:pPr indent="0" marL="0">
+            <a:pPr marL="0" indent="0">
               <a:buNone/>
             </a:pPr>
             <a:r>
@@ -2868,7 +2551,7 @@
           </a:solidFill>
           <a:ln/>
           <a:effectLst>
-            <a:outerShdw sx="100000" sy="100000" kx="0" ky="0" algn="bl" rotWithShape="0" blurRad="101600" dist="38100" dir="8100000">
+            <a:outerShdw blurRad="101600" dist="38100" dir="8100000" algn="bl" rotWithShape="0">
               <a:srgbClr val="000000">
                 <a:alpha val="25000"/>
               </a:srgbClr>
@@ -2897,7 +2580,7 @@
           <a:bodyPr wrap="square" lIns="0" tIns="0" rIns="0" bIns="0" rtlCol="0" anchor="ctr"/>
           <a:lstStyle/>
           <a:p>
-            <a:pPr indent="0" marL="0">
+            <a:pPr marL="0" indent="0">
               <a:buNone/>
             </a:pPr>
             <a:r>
@@ -2976,7 +2659,7 @@
           <a:bodyPr wrap="square" lIns="0" tIns="0" rIns="0" bIns="0" rtlCol="0" anchor="ctr"/>
           <a:lstStyle/>
           <a:p>
-            <a:pPr indent="0" marL="0">
+            <a:pPr marL="0" indent="0">
               <a:buNone/>
             </a:pPr>
             <a:r>
@@ -3015,7 +2698,7 @@
           <a:bodyPr wrap="square" lIns="0" tIns="0" rIns="0" bIns="0" rtlCol="0" anchor="ctr"/>
           <a:lstStyle/>
           <a:p>
-            <a:pPr indent="0" marL="0">
+            <a:pPr marL="0" indent="0">
               <a:buNone/>
             </a:pPr>
             <a:r>
@@ -3054,7 +2737,7 @@
           <a:bodyPr wrap="square" lIns="0" tIns="0" rIns="0" bIns="0" rtlCol="0" anchor="ctr"/>
           <a:lstStyle/>
           <a:p>
-            <a:pPr indent="0" marL="0">
+            <a:pPr marL="0" indent="0">
               <a:buNone/>
             </a:pPr>
             <a:r>
@@ -3093,7 +2776,7 @@
           <a:bodyPr wrap="square" lIns="0" tIns="0" rIns="0" bIns="0" rtlCol="0" anchor="ctr"/>
           <a:lstStyle/>
           <a:p>
-            <a:pPr indent="0" marL="0">
+            <a:pPr marL="0" indent="0">
               <a:buNone/>
             </a:pPr>
             <a:r>
@@ -3132,7 +2815,7 @@
           <a:bodyPr wrap="square" lIns="0" tIns="0" rIns="0" bIns="0" rtlCol="0" anchor="ctr"/>
           <a:lstStyle/>
           <a:p>
-            <a:pPr indent="0" marL="0">
+            <a:pPr marL="0" indent="0">
               <a:buNone/>
             </a:pPr>
             <a:r>
@@ -3149,7 +2832,7 @@
             <a:endParaRPr lang="en-US" sz="1100" dirty="0"/>
           </a:p>
           <a:p>
-            <a:pPr indent="0" marL="0">
+            <a:pPr marL="0" indent="0">
               <a:buNone/>
             </a:pPr>
             <a:r>
@@ -3188,7 +2871,7 @@
           <a:bodyPr wrap="square" lIns="0" tIns="0" rIns="0" bIns="0" rtlCol="0" anchor="ctr"/>
           <a:lstStyle/>
           <a:p>
-            <a:pPr indent="0" marL="0">
+            <a:pPr marL="0" indent="0">
               <a:buNone/>
             </a:pPr>
             <a:r>
@@ -3252,7 +2935,7 @@
           <a:bodyPr wrap="square" lIns="0" tIns="0" rIns="0" bIns="0" rtlCol="0" anchor="ctr"/>
           <a:lstStyle/>
           <a:p>
-            <a:pPr indent="0" marL="0">
+            <a:pPr marL="0" indent="0">
               <a:buNone/>
             </a:pPr>
             <a:r>
@@ -3269,13 +2952,13 @@
             <a:endParaRPr lang="en-US" sz="1100" dirty="0"/>
           </a:p>
           <a:p>
-            <a:pPr indent="0" marL="0">
+            <a:pPr marL="0" indent="0">
               <a:buNone/>
             </a:pPr>
             <a:endParaRPr lang="en-US" sz="1100" dirty="0"/>
           </a:p>
           <a:p>
-            <a:pPr indent="0" marL="0">
+            <a:pPr marL="0" indent="0">
               <a:buNone/>
             </a:pPr>
             <a:r>
@@ -3292,7 +2975,7 @@
             <a:endParaRPr lang="en-US" sz="1100" dirty="0"/>
           </a:p>
           <a:p>
-            <a:pPr indent="0" marL="0">
+            <a:pPr marL="0" indent="0">
               <a:buNone/>
             </a:pPr>
             <a:r>
@@ -3309,13 +2992,13 @@
             <a:endParaRPr lang="en-US" sz="1100" dirty="0"/>
           </a:p>
           <a:p>
-            <a:pPr indent="0" marL="0">
+            <a:pPr marL="0" indent="0">
               <a:buNone/>
             </a:pPr>
             <a:endParaRPr lang="en-US" sz="1100" dirty="0"/>
           </a:p>
           <a:p>
-            <a:pPr indent="0" marL="0">
+            <a:pPr marL="0" indent="0">
               <a:buNone/>
             </a:pPr>
             <a:r>
@@ -3332,7 +3015,7 @@
             <a:endParaRPr lang="en-US" sz="1100" dirty="0"/>
           </a:p>
           <a:p>
-            <a:pPr indent="0" marL="0">
+            <a:pPr marL="0" indent="0">
               <a:buNone/>
             </a:pPr>
             <a:r>
@@ -3349,7 +3032,7 @@
             <a:endParaRPr lang="en-US" sz="1100" dirty="0"/>
           </a:p>
           <a:p>
-            <a:pPr indent="0" marL="0">
+            <a:pPr marL="0" indent="0">
               <a:buNone/>
             </a:pPr>
             <a:r>
@@ -3366,7 +3049,7 @@
             <a:endParaRPr lang="en-US" sz="1100" dirty="0"/>
           </a:p>
           <a:p>
-            <a:pPr indent="0" marL="0">
+            <a:pPr marL="0" indent="0">
               <a:buNone/>
             </a:pPr>
             <a:r>
@@ -3383,7 +3066,7 @@
             <a:endParaRPr lang="en-US" sz="1100" dirty="0"/>
           </a:p>
           <a:p>
-            <a:pPr indent="0" marL="0">
+            <a:pPr marL="0" indent="0">
               <a:buNone/>
             </a:pPr>
             <a:r>
@@ -3400,7 +3083,7 @@
             <a:endParaRPr lang="en-US" sz="1100" dirty="0"/>
           </a:p>
           <a:p>
-            <a:pPr indent="0" marL="0">
+            <a:pPr marL="0" indent="0">
               <a:buNone/>
             </a:pPr>
             <a:r>
@@ -3417,7 +3100,7 @@
             <a:endParaRPr lang="en-US" sz="1100" dirty="0"/>
           </a:p>
           <a:p>
-            <a:pPr indent="0" marL="0">
+            <a:pPr marL="0" indent="0">
               <a:buNone/>
             </a:pPr>
             <a:r>
@@ -3434,7 +3117,7 @@
             <a:endParaRPr lang="en-US" sz="1100" dirty="0"/>
           </a:p>
           <a:p>
-            <a:pPr indent="0" marL="0">
+            <a:pPr marL="0" indent="0">
               <a:buNone/>
             </a:pPr>
             <a:r>
@@ -3451,7 +3134,7 @@
             <a:endParaRPr lang="en-US" sz="1100" dirty="0"/>
           </a:p>
           <a:p>
-            <a:pPr indent="0" marL="0">
+            <a:pPr marL="0" indent="0">
               <a:buNone/>
             </a:pPr>
             <a:r>
@@ -3468,13 +3151,13 @@
             <a:endParaRPr lang="en-US" sz="1100" dirty="0"/>
           </a:p>
           <a:p>
-            <a:pPr indent="0" marL="0">
+            <a:pPr marL="0" indent="0">
               <a:buNone/>
             </a:pPr>
             <a:endParaRPr lang="en-US" sz="1100" dirty="0"/>
           </a:p>
           <a:p>
-            <a:pPr indent="0" marL="0">
+            <a:pPr marL="0" indent="0">
               <a:buNone/>
             </a:pPr>
             <a:r>
@@ -3491,7 +3174,7 @@
             <a:endParaRPr lang="en-US" sz="1100" dirty="0"/>
           </a:p>
           <a:p>
-            <a:pPr indent="0" marL="0">
+            <a:pPr marL="0" indent="0">
               <a:buNone/>
             </a:pPr>
             <a:r>
@@ -3525,6 +3208,7 @@
         <a:solidFill>
           <a:srgbClr val="0D1B2A"/>
         </a:solidFill>
+        <a:effectLst/>
       </p:bgPr>
     </p:bg>
     <p:spTree>
@@ -3602,7 +3286,7 @@
           <a:bodyPr wrap="square" lIns="0" tIns="0" rIns="0" bIns="0" rtlCol="0" anchor="ctr"/>
           <a:lstStyle/>
           <a:p>
-            <a:pPr indent="0" marL="0">
+            <a:pPr marL="0" indent="0">
               <a:buNone/>
             </a:pPr>
             <a:r>
@@ -3641,7 +3325,7 @@
           <a:bodyPr wrap="square" lIns="0" tIns="0" rIns="0" bIns="0" rtlCol="0" anchor="ctr"/>
           <a:lstStyle/>
           <a:p>
-            <a:pPr indent="0" marL="0">
+            <a:pPr marL="0" indent="0">
               <a:buNone/>
             </a:pPr>
             <a:r>
@@ -3678,7 +3362,7 @@
           </a:solidFill>
           <a:ln/>
           <a:effectLst>
-            <a:outerShdw sx="100000" sy="100000" kx="0" ky="0" algn="bl" rotWithShape="0" blurRad="101600" dist="38100" dir="8100000">
+            <a:outerShdw blurRad="101600" dist="38100" dir="8100000" algn="bl" rotWithShape="0">
               <a:srgbClr val="000000">
                 <a:alpha val="25000"/>
               </a:srgbClr>
@@ -3747,7 +3431,7 @@
           <a:bodyPr wrap="square" rtlCol="0" anchor="ctr"/>
           <a:lstStyle/>
           <a:p>
-            <a:pPr algn="ctr" indent="0" marL="0">
+            <a:pPr marL="0" indent="0" algn="ctr">
               <a:buNone/>
             </a:pPr>
             <a:r>
@@ -3786,7 +3470,7 @@
           <a:bodyPr wrap="square" lIns="0" tIns="0" rIns="0" bIns="0" rtlCol="0" anchor="ctr"/>
           <a:lstStyle/>
           <a:p>
-            <a:pPr indent="0" marL="0">
+            <a:pPr marL="0" indent="0">
               <a:buNone/>
             </a:pPr>
             <a:r>
@@ -3825,7 +3509,7 @@
           <a:bodyPr wrap="square" lIns="0" tIns="0" rIns="0" bIns="0" rtlCol="0" anchor="ctr"/>
           <a:lstStyle/>
           <a:p>
-            <a:pPr indent="0" marL="0">
+            <a:pPr marL="0" indent="0">
               <a:buNone/>
             </a:pPr>
             <a:r>
@@ -3862,7 +3546,7 @@
           </a:solidFill>
           <a:ln/>
           <a:effectLst>
-            <a:outerShdw sx="100000" sy="100000" kx="0" ky="0" algn="bl" rotWithShape="0" blurRad="101600" dist="38100" dir="8100000">
+            <a:outerShdw blurRad="101600" dist="38100" dir="8100000" algn="bl" rotWithShape="0">
               <a:srgbClr val="000000">
                 <a:alpha val="25000"/>
               </a:srgbClr>
@@ -3931,7 +3615,7 @@
           <a:bodyPr wrap="square" rtlCol="0" anchor="ctr"/>
           <a:lstStyle/>
           <a:p>
-            <a:pPr algn="ctr" indent="0" marL="0">
+            <a:pPr marL="0" indent="0" algn="ctr">
               <a:buNone/>
             </a:pPr>
             <a:r>
@@ -3970,7 +3654,7 @@
           <a:bodyPr wrap="square" lIns="0" tIns="0" rIns="0" bIns="0" rtlCol="0" anchor="ctr"/>
           <a:lstStyle/>
           <a:p>
-            <a:pPr indent="0" marL="0">
+            <a:pPr marL="0" indent="0">
               <a:buNone/>
             </a:pPr>
             <a:r>
@@ -4009,7 +3693,7 @@
           <a:bodyPr wrap="square" lIns="0" tIns="0" rIns="0" bIns="0" rtlCol="0" anchor="ctr"/>
           <a:lstStyle/>
           <a:p>
-            <a:pPr indent="0" marL="0">
+            <a:pPr marL="0" indent="0">
               <a:buNone/>
             </a:pPr>
             <a:r>
@@ -4046,7 +3730,7 @@
           </a:solidFill>
           <a:ln/>
           <a:effectLst>
-            <a:outerShdw sx="100000" sy="100000" kx="0" ky="0" algn="bl" rotWithShape="0" blurRad="101600" dist="38100" dir="8100000">
+            <a:outerShdw blurRad="101600" dist="38100" dir="8100000" algn="bl" rotWithShape="0">
               <a:srgbClr val="000000">
                 <a:alpha val="25000"/>
               </a:srgbClr>
@@ -4115,7 +3799,7 @@
           <a:bodyPr wrap="square" rtlCol="0" anchor="ctr"/>
           <a:lstStyle/>
           <a:p>
-            <a:pPr algn="ctr" indent="0" marL="0">
+            <a:pPr marL="0" indent="0" algn="ctr">
               <a:buNone/>
             </a:pPr>
             <a:r>
@@ -4154,7 +3838,7 @@
           <a:bodyPr wrap="square" lIns="0" tIns="0" rIns="0" bIns="0" rtlCol="0" anchor="ctr"/>
           <a:lstStyle/>
           <a:p>
-            <a:pPr indent="0" marL="0">
+            <a:pPr marL="0" indent="0">
               <a:buNone/>
             </a:pPr>
             <a:r>
@@ -4193,7 +3877,7 @@
           <a:bodyPr wrap="square" lIns="0" tIns="0" rIns="0" bIns="0" rtlCol="0" anchor="ctr"/>
           <a:lstStyle/>
           <a:p>
-            <a:pPr indent="0" marL="0">
+            <a:pPr marL="0" indent="0">
               <a:buNone/>
             </a:pPr>
             <a:r>
@@ -4230,7 +3914,7 @@
           </a:solidFill>
           <a:ln/>
           <a:effectLst>
-            <a:outerShdw sx="100000" sy="100000" kx="0" ky="0" algn="bl" rotWithShape="0" blurRad="101600" dist="38100" dir="8100000">
+            <a:outerShdw blurRad="101600" dist="38100" dir="8100000" algn="bl" rotWithShape="0">
               <a:srgbClr val="000000">
                 <a:alpha val="25000"/>
               </a:srgbClr>
@@ -4299,7 +3983,7 @@
           <a:bodyPr wrap="square" rtlCol="0" anchor="ctr"/>
           <a:lstStyle/>
           <a:p>
-            <a:pPr algn="ctr" indent="0" marL="0">
+            <a:pPr marL="0" indent="0" algn="ctr">
               <a:buNone/>
             </a:pPr>
             <a:r>
@@ -4338,7 +4022,7 @@
           <a:bodyPr wrap="square" lIns="0" tIns="0" rIns="0" bIns="0" rtlCol="0" anchor="ctr"/>
           <a:lstStyle/>
           <a:p>
-            <a:pPr indent="0" marL="0">
+            <a:pPr marL="0" indent="0">
               <a:buNone/>
             </a:pPr>
             <a:r>
@@ -4377,7 +4061,7 @@
           <a:bodyPr wrap="square" lIns="0" tIns="0" rIns="0" bIns="0" rtlCol="0" anchor="ctr"/>
           <a:lstStyle/>
           <a:p>
-            <a:pPr indent="0" marL="0">
+            <a:pPr marL="0" indent="0">
               <a:buNone/>
             </a:pPr>
             <a:r>
@@ -4414,7 +4098,7 @@
           </a:solidFill>
           <a:ln/>
           <a:effectLst>
-            <a:outerShdw sx="100000" sy="100000" kx="0" ky="0" algn="bl" rotWithShape="0" blurRad="101600" dist="38100" dir="8100000">
+            <a:outerShdw blurRad="101600" dist="38100" dir="8100000" algn="bl" rotWithShape="0">
               <a:srgbClr val="000000">
                 <a:alpha val="25000"/>
               </a:srgbClr>
@@ -4483,7 +4167,7 @@
           <a:bodyPr wrap="square" rtlCol="0" anchor="ctr"/>
           <a:lstStyle/>
           <a:p>
-            <a:pPr algn="ctr" indent="0" marL="0">
+            <a:pPr marL="0" indent="0" algn="ctr">
               <a:buNone/>
             </a:pPr>
             <a:r>
@@ -4522,7 +4206,7 @@
           <a:bodyPr wrap="square" lIns="0" tIns="0" rIns="0" bIns="0" rtlCol="0" anchor="ctr"/>
           <a:lstStyle/>
           <a:p>
-            <a:pPr indent="0" marL="0">
+            <a:pPr marL="0" indent="0">
               <a:buNone/>
             </a:pPr>
             <a:r>
@@ -4561,7 +4245,7 @@
           <a:bodyPr wrap="square" lIns="0" tIns="0" rIns="0" bIns="0" rtlCol="0" anchor="ctr"/>
           <a:lstStyle/>
           <a:p>
-            <a:pPr indent="0" marL="0">
+            <a:pPr marL="0" indent="0">
               <a:buNone/>
             </a:pPr>
             <a:r>
@@ -4595,6 +4279,7 @@
         <a:solidFill>
           <a:srgbClr val="0D1B2A"/>
         </a:solidFill>
+        <a:effectLst/>
       </p:bgPr>
     </p:bg>
     <p:spTree>
@@ -4672,7 +4357,7 @@
           <a:bodyPr wrap="square" lIns="0" tIns="0" rIns="0" bIns="0" rtlCol="0" anchor="ctr"/>
           <a:lstStyle/>
           <a:p>
-            <a:pPr indent="0" marL="0">
+            <a:pPr marL="0" indent="0">
               <a:buNone/>
             </a:pPr>
             <a:r>
@@ -4709,7 +4394,7 @@
           </a:solidFill>
           <a:ln/>
           <a:effectLst>
-            <a:outerShdw sx="100000" sy="100000" kx="0" ky="0" algn="bl" rotWithShape="0" blurRad="101600" dist="38100" dir="8100000">
+            <a:outerShdw blurRad="101600" dist="38100" dir="8100000" algn="bl" rotWithShape="0">
               <a:srgbClr val="000000">
                 <a:alpha val="25000"/>
               </a:srgbClr>
@@ -4758,7 +4443,7 @@
           <a:bodyPr wrap="square" lIns="0" tIns="0" rIns="0" bIns="0" rtlCol="0" anchor="ctr"/>
           <a:lstStyle/>
           <a:p>
-            <a:pPr indent="0" marL="0">
+            <a:pPr marL="0" indent="0">
               <a:buNone/>
             </a:pPr>
             <a:r>
@@ -4797,7 +4482,7 @@
           <a:bodyPr wrap="square" lIns="0" tIns="0" rIns="0" bIns="0" rtlCol="0" anchor="ctr"/>
           <a:lstStyle/>
           <a:p>
-            <a:pPr indent="0" marL="0">
+            <a:pPr marL="0" indent="0">
               <a:buNone/>
             </a:pPr>
             <a:r>
@@ -4856,7 +4541,7 @@
           <a:bodyPr wrap="square" lIns="0" tIns="0" rIns="0" bIns="0" rtlCol="0" anchor="ctr"/>
           <a:lstStyle/>
           <a:p>
-            <a:pPr indent="0" marL="0">
+            <a:pPr marL="0" indent="0">
               <a:buNone/>
             </a:pPr>
             <a:r>
@@ -4915,7 +4600,7 @@
           <a:bodyPr wrap="square" lIns="0" tIns="0" rIns="0" bIns="0" rtlCol="0" anchor="ctr"/>
           <a:lstStyle/>
           <a:p>
-            <a:pPr indent="0" marL="0">
+            <a:pPr marL="0" indent="0">
               <a:buNone/>
             </a:pPr>
             <a:r>
@@ -4974,7 +4659,7 @@
           <a:bodyPr wrap="square" lIns="0" tIns="0" rIns="0" bIns="0" rtlCol="0" anchor="ctr"/>
           <a:lstStyle/>
           <a:p>
-            <a:pPr indent="0" marL="0">
+            <a:pPr marL="0" indent="0">
               <a:buNone/>
             </a:pPr>
             <a:r>
@@ -5033,7 +4718,7 @@
           <a:bodyPr wrap="square" lIns="0" tIns="0" rIns="0" bIns="0" rtlCol="0" anchor="ctr"/>
           <a:lstStyle/>
           <a:p>
-            <a:pPr indent="0" marL="0">
+            <a:pPr marL="0" indent="0">
               <a:buNone/>
             </a:pPr>
             <a:r>
@@ -5092,7 +4777,7 @@
           <a:bodyPr wrap="square" lIns="0" tIns="0" rIns="0" bIns="0" rtlCol="0" anchor="ctr"/>
           <a:lstStyle/>
           <a:p>
-            <a:pPr indent="0" marL="0">
+            <a:pPr marL="0" indent="0">
               <a:buNone/>
             </a:pPr>
             <a:r>
@@ -5129,7 +4814,7 @@
           </a:solidFill>
           <a:ln/>
           <a:effectLst>
-            <a:outerShdw sx="100000" sy="100000" kx="0" ky="0" algn="bl" rotWithShape="0" blurRad="101600" dist="38100" dir="8100000">
+            <a:outerShdw blurRad="101600" dist="38100" dir="8100000" algn="bl" rotWithShape="0">
               <a:srgbClr val="000000">
                 <a:alpha val="25000"/>
               </a:srgbClr>
@@ -5178,7 +4863,7 @@
           <a:bodyPr wrap="square" lIns="0" tIns="0" rIns="0" bIns="0" rtlCol="0" anchor="ctr"/>
           <a:lstStyle/>
           <a:p>
-            <a:pPr indent="0" marL="0">
+            <a:pPr marL="0" indent="0">
               <a:buNone/>
             </a:pPr>
             <a:r>
@@ -5217,7 +4902,7 @@
           <a:bodyPr wrap="square" lIns="0" tIns="0" rIns="0" bIns="0" rtlCol="0" anchor="ctr"/>
           <a:lstStyle/>
           <a:p>
-            <a:pPr indent="0" marL="0">
+            <a:pPr marL="0" indent="0">
               <a:buNone/>
             </a:pPr>
             <a:r>
@@ -5276,7 +4961,7 @@
           <a:bodyPr wrap="square" lIns="0" tIns="0" rIns="0" bIns="0" rtlCol="0" anchor="ctr"/>
           <a:lstStyle/>
           <a:p>
-            <a:pPr indent="0" marL="0">
+            <a:pPr marL="0" indent="0">
               <a:buNone/>
             </a:pPr>
             <a:r>
@@ -5335,7 +5020,7 @@
           <a:bodyPr wrap="square" lIns="0" tIns="0" rIns="0" bIns="0" rtlCol="0" anchor="ctr"/>
           <a:lstStyle/>
           <a:p>
-            <a:pPr indent="0" marL="0">
+            <a:pPr marL="0" indent="0">
               <a:buNone/>
             </a:pPr>
             <a:r>
@@ -5394,7 +5079,7 @@
           <a:bodyPr wrap="square" lIns="0" tIns="0" rIns="0" bIns="0" rtlCol="0" anchor="ctr"/>
           <a:lstStyle/>
           <a:p>
-            <a:pPr indent="0" marL="0">
+            <a:pPr marL="0" indent="0">
               <a:buNone/>
             </a:pPr>
             <a:r>
@@ -5453,7 +5138,7 @@
           <a:bodyPr wrap="square" lIns="0" tIns="0" rIns="0" bIns="0" rtlCol="0" anchor="ctr"/>
           <a:lstStyle/>
           <a:p>
-            <a:pPr indent="0" marL="0">
+            <a:pPr marL="0" indent="0">
               <a:buNone/>
             </a:pPr>
             <a:r>
@@ -5512,7 +5197,7 @@
           <a:bodyPr wrap="square" lIns="0" tIns="0" rIns="0" bIns="0" rtlCol="0" anchor="ctr"/>
           <a:lstStyle/>
           <a:p>
-            <a:pPr indent="0" marL="0">
+            <a:pPr marL="0" indent="0">
               <a:buNone/>
             </a:pPr>
             <a:r>
@@ -5549,7 +5234,7 @@
           </a:solidFill>
           <a:ln/>
           <a:effectLst>
-            <a:outerShdw sx="100000" sy="100000" kx="0" ky="0" algn="bl" rotWithShape="0" blurRad="101600" dist="38100" dir="8100000">
+            <a:outerShdw blurRad="101600" dist="38100" dir="8100000" algn="bl" rotWithShape="0">
               <a:srgbClr val="000000">
                 <a:alpha val="25000"/>
               </a:srgbClr>
@@ -5598,7 +5283,7 @@
           <a:bodyPr wrap="square" lIns="0" tIns="0" rIns="0" bIns="0" rtlCol="0" anchor="ctr"/>
           <a:lstStyle/>
           <a:p>
-            <a:pPr indent="0" marL="0">
+            <a:pPr marL="0" indent="0">
               <a:buNone/>
             </a:pPr>
             <a:r>
@@ -5637,7 +5322,7 @@
           <a:bodyPr wrap="square" lIns="0" tIns="0" rIns="0" bIns="0" rtlCol="0" anchor="ctr"/>
           <a:lstStyle/>
           <a:p>
-            <a:pPr indent="0" marL="0">
+            <a:pPr marL="0" indent="0">
               <a:buNone/>
             </a:pPr>
             <a:r>
@@ -5696,7 +5381,7 @@
           <a:bodyPr wrap="square" lIns="0" tIns="0" rIns="0" bIns="0" rtlCol="0" anchor="ctr"/>
           <a:lstStyle/>
           <a:p>
-            <a:pPr indent="0" marL="0">
+            <a:pPr marL="0" indent="0">
               <a:buNone/>
             </a:pPr>
             <a:r>
@@ -5755,7 +5440,7 @@
           <a:bodyPr wrap="square" lIns="0" tIns="0" rIns="0" bIns="0" rtlCol="0" anchor="ctr"/>
           <a:lstStyle/>
           <a:p>
-            <a:pPr indent="0" marL="0">
+            <a:pPr marL="0" indent="0">
               <a:buNone/>
             </a:pPr>
             <a:r>
@@ -5814,7 +5499,7 @@
           <a:bodyPr wrap="square" lIns="0" tIns="0" rIns="0" bIns="0" rtlCol="0" anchor="ctr"/>
           <a:lstStyle/>
           <a:p>
-            <a:pPr indent="0" marL="0">
+            <a:pPr marL="0" indent="0">
               <a:buNone/>
             </a:pPr>
             <a:r>
@@ -5873,7 +5558,7 @@
           <a:bodyPr wrap="square" lIns="0" tIns="0" rIns="0" bIns="0" rtlCol="0" anchor="ctr"/>
           <a:lstStyle/>
           <a:p>
-            <a:pPr indent="0" marL="0">
+            <a:pPr marL="0" indent="0">
               <a:buNone/>
             </a:pPr>
             <a:r>
@@ -5932,7 +5617,7 @@
           <a:bodyPr wrap="square" lIns="0" tIns="0" rIns="0" bIns="0" rtlCol="0" anchor="ctr"/>
           <a:lstStyle/>
           <a:p>
-            <a:pPr indent="0" marL="0">
+            <a:pPr marL="0" indent="0">
               <a:buNone/>
             </a:pPr>
             <a:r>
@@ -5966,6 +5651,7 @@
         <a:solidFill>
           <a:srgbClr val="0D1B2A"/>
         </a:solidFill>
+        <a:effectLst/>
       </p:bgPr>
     </p:bg>
     <p:spTree>
@@ -6093,7 +5779,7 @@
           <a:bodyPr wrap="square" rtlCol="0" anchor="ctr"/>
           <a:lstStyle/>
           <a:p>
-            <a:pPr algn="ctr" indent="0" marL="0">
+            <a:pPr marL="0" indent="0" algn="ctr">
               <a:buNone/>
             </a:pPr>
             <a:r>
@@ -6132,7 +5818,7 @@
           <a:bodyPr wrap="square" lIns="0" tIns="0" rIns="0" bIns="0" rtlCol="0" anchor="ctr"/>
           <a:lstStyle/>
           <a:p>
-            <a:pPr algn="ctr" indent="0" marL="0">
+            <a:pPr marL="0" indent="0" algn="ctr">
               <a:buNone/>
             </a:pPr>
             <a:r>
@@ -6171,7 +5857,7 @@
           <a:bodyPr wrap="square" lIns="0" tIns="0" rIns="0" bIns="0" rtlCol="0" anchor="ctr"/>
           <a:lstStyle/>
           <a:p>
-            <a:pPr algn="ctr" indent="0" marL="0">
+            <a:pPr marL="0" indent="0" algn="ctr">
               <a:buNone/>
             </a:pPr>
             <a:r>
@@ -6235,7 +5921,7 @@
           <a:bodyPr wrap="square" rtlCol="0" anchor="ctr"/>
           <a:lstStyle/>
           <a:p>
-            <a:pPr algn="ctr" indent="0" marL="0">
+            <a:pPr marL="0" indent="0" algn="ctr">
               <a:buNone/>
             </a:pPr>
             <a:r>
@@ -6274,7 +5960,7 @@
           <a:bodyPr wrap="square" lIns="0" tIns="0" rIns="0" bIns="0" rtlCol="0" anchor="ctr"/>
           <a:lstStyle/>
           <a:p>
-            <a:pPr algn="ctr" indent="0" marL="0">
+            <a:pPr marL="0" indent="0" algn="ctr">
               <a:buNone/>
             </a:pPr>
             <a:r>
@@ -6291,7 +5977,7 @@
             <a:endParaRPr lang="en-US" sz="1000" dirty="0"/>
           </a:p>
           <a:p>
-            <a:pPr algn="ctr" indent="0" marL="0">
+            <a:pPr marL="0" indent="0" algn="ctr">
               <a:buNone/>
             </a:pPr>
             <a:r>
@@ -6355,7 +6041,7 @@
           <a:bodyPr wrap="square" rtlCol="0" anchor="ctr"/>
           <a:lstStyle/>
           <a:p>
-            <a:pPr algn="ctr" indent="0" marL="0">
+            <a:pPr marL="0" indent="0" algn="ctr">
               <a:buNone/>
             </a:pPr>
             <a:r>
@@ -6394,7 +6080,7 @@
           <a:bodyPr wrap="square" lIns="0" tIns="0" rIns="0" bIns="0" rtlCol="0" anchor="ctr"/>
           <a:lstStyle/>
           <a:p>
-            <a:pPr algn="ctr" indent="0" marL="0">
+            <a:pPr marL="0" indent="0" algn="ctr">
               <a:buNone/>
             </a:pPr>
             <a:r>
@@ -6411,7 +6097,7 @@
             <a:endParaRPr lang="en-US" sz="1000" dirty="0"/>
           </a:p>
           <a:p>
-            <a:pPr algn="ctr" indent="0" marL="0">
+            <a:pPr marL="0" indent="0" algn="ctr">
               <a:buNone/>
             </a:pPr>
             <a:r>
@@ -6475,7 +6161,7 @@
           <a:bodyPr wrap="square" rtlCol="0" anchor="ctr"/>
           <a:lstStyle/>
           <a:p>
-            <a:pPr algn="ctr" indent="0" marL="0">
+            <a:pPr marL="0" indent="0" algn="ctr">
               <a:buNone/>
             </a:pPr>
             <a:r>
@@ -6514,7 +6200,7 @@
           <a:bodyPr wrap="square" lIns="0" tIns="0" rIns="0" bIns="0" rtlCol="0" anchor="ctr"/>
           <a:lstStyle/>
           <a:p>
-            <a:pPr algn="ctr" indent="0" marL="0">
+            <a:pPr marL="0" indent="0" algn="ctr">
               <a:buNone/>
             </a:pPr>
             <a:r>
@@ -6531,7 +6217,7 @@
             <a:endParaRPr lang="en-US" sz="1000" dirty="0"/>
           </a:p>
           <a:p>
-            <a:pPr algn="ctr" indent="0" marL="0">
+            <a:pPr marL="0" indent="0" algn="ctr">
               <a:buNone/>
             </a:pPr>
             <a:r>
@@ -6595,7 +6281,7 @@
           <a:bodyPr wrap="square" rtlCol="0" anchor="ctr"/>
           <a:lstStyle/>
           <a:p>
-            <a:pPr algn="ctr" indent="0" marL="0">
+            <a:pPr marL="0" indent="0" algn="ctr">
               <a:buNone/>
             </a:pPr>
             <a:r>
@@ -6634,7 +6320,7 @@
           <a:bodyPr wrap="square" lIns="0" tIns="0" rIns="0" bIns="0" rtlCol="0" anchor="ctr"/>
           <a:lstStyle/>
           <a:p>
-            <a:pPr algn="ctr" indent="0" marL="0">
+            <a:pPr marL="0" indent="0" algn="ctr">
               <a:buNone/>
             </a:pPr>
             <a:r>
@@ -6651,7 +6337,7 @@
             <a:endParaRPr lang="en-US" sz="1000" dirty="0"/>
           </a:p>
           <a:p>
-            <a:pPr algn="ctr" indent="0" marL="0">
+            <a:pPr marL="0" indent="0" algn="ctr">
               <a:buNone/>
             </a:pPr>
             <a:r>
@@ -6690,7 +6376,7 @@
           <a:bodyPr wrap="square" lIns="0" tIns="0" rIns="0" bIns="0" rtlCol="0" anchor="ctr"/>
           <a:lstStyle/>
           <a:p>
-            <a:pPr algn="ctr" indent="0" marL="0">
+            <a:pPr marL="0" indent="0" algn="ctr">
               <a:buNone/>
             </a:pPr>
             <a:r>
@@ -6724,6 +6410,7 @@
         <a:solidFill>
           <a:srgbClr val="0D1B2A"/>
         </a:solidFill>
+        <a:effectLst/>
       </p:bgPr>
     </p:bg>
     <p:spTree>
@@ -6801,7 +6488,7 @@
           <a:bodyPr wrap="square" lIns="0" tIns="0" rIns="0" bIns="0" rtlCol="0" anchor="ctr"/>
           <a:lstStyle/>
           <a:p>
-            <a:pPr indent="0" marL="0">
+            <a:pPr marL="0" indent="0">
               <a:buNone/>
             </a:pPr>
             <a:r>
@@ -6840,7 +6527,7 @@
           <a:bodyPr wrap="square" lIns="0" tIns="0" rIns="0" bIns="0" rtlCol="0" anchor="ctr"/>
           <a:lstStyle/>
           <a:p>
-            <a:pPr indent="0" marL="0">
+            <a:pPr marL="0" indent="0">
               <a:buNone/>
             </a:pPr>
             <a:r>
@@ -6877,7 +6564,7 @@
           </a:solidFill>
           <a:ln/>
           <a:effectLst>
-            <a:outerShdw sx="100000" sy="100000" kx="0" ky="0" algn="bl" rotWithShape="0" blurRad="101600" dist="38100" dir="8100000">
+            <a:outerShdw blurRad="101600" dist="38100" dir="8100000" algn="bl" rotWithShape="0">
               <a:srgbClr val="000000">
                 <a:alpha val="25000"/>
               </a:srgbClr>
@@ -6926,7 +6613,7 @@
           <a:bodyPr wrap="square" lIns="0" tIns="0" rIns="0" bIns="0" rtlCol="0" anchor="ctr"/>
           <a:lstStyle/>
           <a:p>
-            <a:pPr indent="0" marL="0">
+            <a:pPr marL="0" indent="0">
               <a:buNone/>
             </a:pPr>
             <a:r>
@@ -6965,7 +6652,7 @@
           <a:bodyPr wrap="square" lIns="0" tIns="0" rIns="0" bIns="0" rtlCol="0" anchor="ctr"/>
           <a:lstStyle/>
           <a:p>
-            <a:pPr indent="0" marL="0">
+            <a:pPr marL="0" indent="0">
               <a:buNone/>
             </a:pPr>
             <a:r>
@@ -7002,7 +6689,7 @@
           </a:solidFill>
           <a:ln/>
           <a:effectLst>
-            <a:outerShdw sx="100000" sy="100000" kx="0" ky="0" algn="bl" rotWithShape="0" blurRad="101600" dist="38100" dir="8100000">
+            <a:outerShdw blurRad="101600" dist="38100" dir="8100000" algn="bl" rotWithShape="0">
               <a:srgbClr val="000000">
                 <a:alpha val="25000"/>
               </a:srgbClr>
@@ -7051,7 +6738,7 @@
           <a:bodyPr wrap="square" lIns="0" tIns="0" rIns="0" bIns="0" rtlCol="0" anchor="ctr"/>
           <a:lstStyle/>
           <a:p>
-            <a:pPr indent="0" marL="0">
+            <a:pPr marL="0" indent="0">
               <a:buNone/>
             </a:pPr>
             <a:r>
@@ -7090,7 +6777,7 @@
           <a:bodyPr wrap="square" lIns="0" tIns="0" rIns="0" bIns="0" rtlCol="0" anchor="ctr"/>
           <a:lstStyle/>
           <a:p>
-            <a:pPr indent="0" marL="0">
+            <a:pPr marL="0" indent="0">
               <a:buNone/>
             </a:pPr>
             <a:r>
@@ -7127,7 +6814,7 @@
           </a:solidFill>
           <a:ln/>
           <a:effectLst>
-            <a:outerShdw sx="100000" sy="100000" kx="0" ky="0" algn="bl" rotWithShape="0" blurRad="101600" dist="38100" dir="8100000">
+            <a:outerShdw blurRad="101600" dist="38100" dir="8100000" algn="bl" rotWithShape="0">
               <a:srgbClr val="000000">
                 <a:alpha val="25000"/>
               </a:srgbClr>
@@ -7156,7 +6843,7 @@
           <a:bodyPr wrap="square" lIns="0" tIns="0" rIns="0" bIns="0" rtlCol="0" anchor="ctr"/>
           <a:lstStyle/>
           <a:p>
-            <a:pPr indent="0" marL="0">
+            <a:pPr marL="0" indent="0">
               <a:buNone/>
             </a:pPr>
             <a:r>
@@ -7220,7 +6907,7 @@
           <a:bodyPr wrap="square" lIns="0" tIns="0" rIns="0" bIns="0" rtlCol="0" anchor="ctr"/>
           <a:lstStyle/>
           <a:p>
-            <a:pPr indent="0" marL="0">
+            <a:pPr marL="0" indent="0">
               <a:buNone/>
             </a:pPr>
             <a:r>
@@ -7284,7 +6971,7 @@
           <a:bodyPr wrap="square" lIns="0" tIns="0" rIns="0" bIns="0" rtlCol="0" anchor="ctr"/>
           <a:lstStyle/>
           <a:p>
-            <a:pPr indent="0" marL="0">
+            <a:pPr marL="0" indent="0">
               <a:buNone/>
             </a:pPr>
             <a:r>
@@ -7348,7 +7035,7 @@
           <a:bodyPr wrap="square" lIns="0" tIns="0" rIns="0" bIns="0" rtlCol="0" anchor="ctr"/>
           <a:lstStyle/>
           <a:p>
-            <a:pPr indent="0" marL="0">
+            <a:pPr marL="0" indent="0">
               <a:buNone/>
             </a:pPr>
             <a:r>
@@ -7412,7 +7099,7 @@
           <a:bodyPr wrap="square" lIns="0" tIns="0" rIns="0" bIns="0" rtlCol="0" anchor="ctr"/>
           <a:lstStyle/>
           <a:p>
-            <a:pPr indent="0" marL="0">
+            <a:pPr marL="0" indent="0">
               <a:buNone/>
             </a:pPr>
             <a:r>
@@ -7451,7 +7138,7 @@
           <a:bodyPr wrap="square" lIns="0" tIns="0" rIns="0" bIns="0" rtlCol="0" anchor="ctr"/>
           <a:lstStyle/>
           <a:p>
-            <a:pPr indent="0" marL="0">
+            <a:pPr marL="0" indent="0">
               <a:buNone/>
             </a:pPr>
             <a:r>
@@ -7468,7 +7155,7 @@
             <a:endParaRPr lang="en-US" sz="1300" dirty="0"/>
           </a:p>
           <a:p>
-            <a:pPr indent="0" marL="0">
+            <a:pPr marL="0" indent="0">
               <a:buNone/>
             </a:pPr>
             <a:r>
@@ -7485,7 +7172,7 @@
             <a:endParaRPr lang="en-US" sz="1300" dirty="0"/>
           </a:p>
           <a:p>
-            <a:pPr indent="0" marL="0">
+            <a:pPr marL="0" indent="0">
               <a:buNone/>
             </a:pPr>
             <a:r>
@@ -7519,6 +7206,7 @@
         <a:solidFill>
           <a:srgbClr val="0D1B2A"/>
         </a:solidFill>
+        <a:effectLst/>
       </p:bgPr>
     </p:bg>
     <p:spTree>
@@ -7596,7 +7284,7 @@
           <a:bodyPr wrap="square" lIns="0" tIns="0" rIns="0" bIns="0" rtlCol="0" anchor="ctr"/>
           <a:lstStyle/>
           <a:p>
-            <a:pPr indent="0" marL="0">
+            <a:pPr marL="0" indent="0">
               <a:buNone/>
             </a:pPr>
             <a:r>
@@ -7635,7 +7323,7 @@
           <a:bodyPr wrap="square" lIns="0" tIns="0" rIns="0" bIns="0" rtlCol="0" anchor="ctr"/>
           <a:lstStyle/>
           <a:p>
-            <a:pPr indent="0" marL="0">
+            <a:pPr marL="0" indent="0">
               <a:buNone/>
             </a:pPr>
             <a:r>
@@ -7672,7 +7360,7 @@
           </a:solidFill>
           <a:ln/>
           <a:effectLst>
-            <a:outerShdw sx="100000" sy="100000" kx="0" ky="0" algn="bl" rotWithShape="0" blurRad="101600" dist="38100" dir="8100000">
+            <a:outerShdw blurRad="101600" dist="38100" dir="8100000" algn="bl" rotWithShape="0">
               <a:srgbClr val="000000">
                 <a:alpha val="25000"/>
               </a:srgbClr>
@@ -7701,7 +7389,7 @@
           <a:bodyPr wrap="square" lIns="0" tIns="0" rIns="0" bIns="0" rtlCol="0" anchor="ctr"/>
           <a:lstStyle/>
           <a:p>
-            <a:pPr indent="0" marL="0">
+            <a:pPr marL="0" indent="0">
               <a:buNone/>
             </a:pPr>
             <a:r>
@@ -7765,7 +7453,7 @@
           <a:bodyPr wrap="square" lIns="0" tIns="0" rIns="0" bIns="0" rtlCol="0" anchor="ctr"/>
           <a:lstStyle/>
           <a:p>
-            <a:pPr algn="ctr" indent="0" marL="0">
+            <a:pPr marL="0" indent="0" algn="ctr">
               <a:buNone/>
             </a:pPr>
             <a:r>
@@ -7829,7 +7517,7 @@
           <a:bodyPr wrap="square" lIns="0" tIns="0" rIns="0" bIns="0" rtlCol="0" anchor="ctr"/>
           <a:lstStyle/>
           <a:p>
-            <a:pPr algn="ctr" indent="0" marL="0">
+            <a:pPr marL="0" indent="0" algn="ctr">
               <a:buNone/>
             </a:pPr>
             <a:r>
@@ -7893,7 +7581,7 @@
           <a:bodyPr wrap="square" lIns="0" tIns="0" rIns="0" bIns="0" rtlCol="0" anchor="ctr"/>
           <a:lstStyle/>
           <a:p>
-            <a:pPr algn="ctr" indent="0" marL="0">
+            <a:pPr marL="0" indent="0" algn="ctr">
               <a:buNone/>
             </a:pPr>
             <a:r>
@@ -7930,7 +7618,7 @@
           </a:solidFill>
           <a:ln/>
           <a:effectLst>
-            <a:outerShdw sx="100000" sy="100000" kx="0" ky="0" algn="bl" rotWithShape="0" blurRad="101600" dist="38100" dir="8100000">
+            <a:outerShdw blurRad="101600" dist="38100" dir="8100000" algn="bl" rotWithShape="0">
               <a:srgbClr val="000000">
                 <a:alpha val="25000"/>
               </a:srgbClr>
@@ -7959,7 +7647,7 @@
           <a:bodyPr wrap="square" lIns="0" tIns="0" rIns="0" bIns="0" rtlCol="0" anchor="ctr"/>
           <a:lstStyle/>
           <a:p>
-            <a:pPr indent="0" marL="0">
+            <a:pPr marL="0" indent="0">
               <a:buNone/>
             </a:pPr>
             <a:r>
@@ -7998,7 +7686,7 @@
           <a:bodyPr wrap="square" lIns="0" tIns="0" rIns="0" bIns="0" rtlCol="0" anchor="ctr"/>
           <a:lstStyle/>
           <a:p>
-            <a:pPr indent="0" marL="0">
+            <a:pPr marL="0" indent="0">
               <a:buNone/>
             </a:pPr>
             <a:r>
@@ -8037,7 +7725,7 @@
           <a:bodyPr wrap="square" lIns="0" tIns="0" rIns="0" bIns="0" rtlCol="0" anchor="ctr"/>
           <a:lstStyle/>
           <a:p>
-            <a:pPr indent="0" marL="0">
+            <a:pPr marL="0" indent="0">
               <a:buNone/>
             </a:pPr>
             <a:r>
@@ -8076,7 +7764,7 @@
           <a:bodyPr wrap="square" lIns="0" tIns="0" rIns="0" bIns="0" rtlCol="0" anchor="ctr"/>
           <a:lstStyle/>
           <a:p>
-            <a:pPr indent="0" marL="0">
+            <a:pPr marL="0" indent="0">
               <a:buNone/>
             </a:pPr>
             <a:r>
@@ -8115,7 +7803,7 @@
           <a:bodyPr wrap="square" lIns="0" tIns="0" rIns="0" bIns="0" rtlCol="0" anchor="ctr"/>
           <a:lstStyle/>
           <a:p>
-            <a:pPr indent="0" marL="0">
+            <a:pPr marL="0" indent="0">
               <a:buNone/>
             </a:pPr>
             <a:r>
@@ -8179,7 +7867,7 @@
           <a:bodyPr wrap="square" lIns="0" tIns="0" rIns="0" bIns="0" rtlCol="0" anchor="ctr"/>
           <a:lstStyle/>
           <a:p>
-            <a:pPr indent="0" marL="0">
+            <a:pPr marL="0" indent="0">
               <a:buNone/>
             </a:pPr>
             <a:r>
@@ -8196,7 +7884,7 @@
             <a:endParaRPr lang="en-US" sz="1100" dirty="0"/>
           </a:p>
           <a:p>
-            <a:pPr indent="0" marL="0">
+            <a:pPr marL="0" indent="0">
               <a:buNone/>
             </a:pPr>
             <a:r>
@@ -8213,7 +7901,7 @@
             <a:endParaRPr lang="en-US" sz="1100" dirty="0"/>
           </a:p>
           <a:p>
-            <a:pPr indent="0" marL="0">
+            <a:pPr marL="0" indent="0">
               <a:buNone/>
             </a:pPr>
             <a:r>
@@ -8230,7 +7918,7 @@
             <a:endParaRPr lang="en-US" sz="1100" dirty="0"/>
           </a:p>
           <a:p>
-            <a:pPr indent="0" marL="0">
+            <a:pPr marL="0" indent="0">
               <a:buNone/>
             </a:pPr>
             <a:r>
@@ -8247,7 +7935,7 @@
             <a:endParaRPr lang="en-US" sz="1100" dirty="0"/>
           </a:p>
           <a:p>
-            <a:pPr indent="0" marL="0">
+            <a:pPr marL="0" indent="0">
               <a:buNone/>
             </a:pPr>
             <a:r>
@@ -8281,6 +7969,7 @@
         <a:solidFill>
           <a:srgbClr val="0D1B2A"/>
         </a:solidFill>
+        <a:effectLst/>
       </p:bgPr>
     </p:bg>
     <p:spTree>
@@ -8358,7 +8047,7 @@
           <a:bodyPr wrap="square" lIns="0" tIns="0" rIns="0" bIns="0" rtlCol="0" anchor="ctr"/>
           <a:lstStyle/>
           <a:p>
-            <a:pPr indent="0" marL="0">
+            <a:pPr marL="0" indent="0">
               <a:buNone/>
             </a:pPr>
             <a:r>
@@ -8397,7 +8086,7 @@
           <a:bodyPr wrap="square" lIns="0" tIns="0" rIns="0" bIns="0" rtlCol="0" anchor="ctr"/>
           <a:lstStyle/>
           <a:p>
-            <a:pPr indent="0" marL="0">
+            <a:pPr marL="0" indent="0">
               <a:buNone/>
             </a:pPr>
             <a:r>
@@ -8434,7 +8123,7 @@
           </a:solidFill>
           <a:ln/>
           <a:effectLst>
-            <a:outerShdw sx="100000" sy="100000" kx="0" ky="0" algn="bl" rotWithShape="0" blurRad="101600" dist="38100" dir="8100000">
+            <a:outerShdw blurRad="101600" dist="38100" dir="8100000" algn="bl" rotWithShape="0">
               <a:srgbClr val="000000">
                 <a:alpha val="25000"/>
               </a:srgbClr>
@@ -8483,7 +8172,7 @@
           <a:bodyPr wrap="square" lIns="0" tIns="0" rIns="0" bIns="0" rtlCol="0" anchor="ctr"/>
           <a:lstStyle/>
           <a:p>
-            <a:pPr indent="0" marL="0">
+            <a:pPr marL="0" indent="0">
               <a:buNone/>
             </a:pPr>
             <a:r>
@@ -8522,7 +8211,7 @@
           <a:bodyPr wrap="square" lIns="0" tIns="0" rIns="0" bIns="0" rtlCol="0" anchor="ctr"/>
           <a:lstStyle/>
           <a:p>
-            <a:pPr indent="0" marL="0">
+            <a:pPr marL="0" indent="0">
               <a:buNone/>
             </a:pPr>
             <a:r>
@@ -8539,7 +8228,7 @@
             <a:endParaRPr lang="en-US" sz="1200" dirty="0"/>
           </a:p>
           <a:p>
-            <a:pPr indent="0" marL="0">
+            <a:pPr marL="0" indent="0">
               <a:buNone/>
             </a:pPr>
             <a:r>
@@ -8578,7 +8267,7 @@
           <a:bodyPr wrap="square" lIns="0" tIns="0" rIns="0" bIns="0" rtlCol="0" anchor="ctr"/>
           <a:lstStyle/>
           <a:p>
-            <a:pPr indent="0" marL="0">
+            <a:pPr marL="0" indent="0">
               <a:buNone/>
             </a:pPr>
             <a:r>
@@ -8637,7 +8326,7 @@
           <a:bodyPr wrap="square" lIns="0" tIns="0" rIns="0" bIns="0" rtlCol="0" anchor="ctr"/>
           <a:lstStyle/>
           <a:p>
-            <a:pPr indent="0" marL="0">
+            <a:pPr marL="0" indent="0">
               <a:buNone/>
             </a:pPr>
             <a:r>
@@ -8696,7 +8385,7 @@
           <a:bodyPr wrap="square" lIns="0" tIns="0" rIns="0" bIns="0" rtlCol="0" anchor="ctr"/>
           <a:lstStyle/>
           <a:p>
-            <a:pPr indent="0" marL="0">
+            <a:pPr marL="0" indent="0">
               <a:buNone/>
             </a:pPr>
             <a:r>
@@ -8755,7 +8444,7 @@
           <a:bodyPr wrap="square" lIns="0" tIns="0" rIns="0" bIns="0" rtlCol="0" anchor="ctr"/>
           <a:lstStyle/>
           <a:p>
-            <a:pPr indent="0" marL="0">
+            <a:pPr marL="0" indent="0">
               <a:buNone/>
             </a:pPr>
             <a:r>
@@ -8792,7 +8481,7 @@
           </a:solidFill>
           <a:ln/>
           <a:effectLst>
-            <a:outerShdw sx="100000" sy="100000" kx="0" ky="0" algn="bl" rotWithShape="0" blurRad="101600" dist="38100" dir="8100000">
+            <a:outerShdw blurRad="101600" dist="38100" dir="8100000" algn="bl" rotWithShape="0">
               <a:srgbClr val="000000">
                 <a:alpha val="25000"/>
               </a:srgbClr>
@@ -8841,7 +8530,7 @@
           <a:bodyPr wrap="square" lIns="0" tIns="0" rIns="0" bIns="0" rtlCol="0" anchor="ctr"/>
           <a:lstStyle/>
           <a:p>
-            <a:pPr indent="0" marL="0">
+            <a:pPr marL="0" indent="0">
               <a:buNone/>
             </a:pPr>
             <a:r>
@@ -8880,7 +8569,7 @@
           <a:bodyPr wrap="square" lIns="0" tIns="0" rIns="0" bIns="0" rtlCol="0" anchor="ctr"/>
           <a:lstStyle/>
           <a:p>
-            <a:pPr indent="0" marL="0">
+            <a:pPr marL="0" indent="0">
               <a:buNone/>
             </a:pPr>
             <a:r>
@@ -8897,7 +8586,7 @@
             <a:endParaRPr lang="en-US" sz="1200" dirty="0"/>
           </a:p>
           <a:p>
-            <a:pPr indent="0" marL="0">
+            <a:pPr marL="0" indent="0">
               <a:buNone/>
             </a:pPr>
             <a:r>
@@ -8936,7 +8625,7 @@
           <a:bodyPr wrap="square" lIns="0" tIns="0" rIns="0" bIns="0" rtlCol="0" anchor="ctr"/>
           <a:lstStyle/>
           <a:p>
-            <a:pPr indent="0" marL="0">
+            <a:pPr marL="0" indent="0">
               <a:buNone/>
             </a:pPr>
             <a:r>
@@ -8995,7 +8684,7 @@
           <a:bodyPr wrap="square" lIns="0" tIns="0" rIns="0" bIns="0" rtlCol="0" anchor="ctr"/>
           <a:lstStyle/>
           <a:p>
-            <a:pPr indent="0" marL="0">
+            <a:pPr marL="0" indent="0">
               <a:buNone/>
             </a:pPr>
             <a:r>
@@ -9054,7 +8743,7 @@
           <a:bodyPr wrap="square" lIns="0" tIns="0" rIns="0" bIns="0" rtlCol="0" anchor="ctr"/>
           <a:lstStyle/>
           <a:p>
-            <a:pPr indent="0" marL="0">
+            <a:pPr marL="0" indent="0">
               <a:buNone/>
             </a:pPr>
             <a:r>
@@ -9113,7 +8802,7 @@
           <a:bodyPr wrap="square" lIns="0" tIns="0" rIns="0" bIns="0" rtlCol="0" anchor="ctr"/>
           <a:lstStyle/>
           <a:p>
-            <a:pPr indent="0" marL="0">
+            <a:pPr marL="0" indent="0">
               <a:buNone/>
             </a:pPr>
             <a:r>
@@ -9177,7 +8866,7 @@
           <a:bodyPr wrap="square" lIns="0" tIns="0" rIns="0" bIns="0" rtlCol="0" anchor="ctr"/>
           <a:lstStyle/>
           <a:p>
-            <a:pPr indent="0" marL="0">
+            <a:pPr marL="0" indent="0">
               <a:buNone/>
             </a:pPr>
             <a:r>
@@ -9194,7 +8883,7 @@
             <a:endParaRPr lang="en-US" sz="1200" dirty="0"/>
           </a:p>
           <a:p>
-            <a:pPr indent="0" marL="0">
+            <a:pPr marL="0" indent="0">
               <a:buNone/>
             </a:pPr>
             <a:r>
@@ -9211,7 +8900,7 @@
             <a:endParaRPr lang="en-US" sz="1200" dirty="0"/>
           </a:p>
           <a:p>
-            <a:pPr indent="0" marL="0">
+            <a:pPr marL="0" indent="0">
               <a:buNone/>
             </a:pPr>
             <a:r>
@@ -9275,7 +8964,7 @@
           <a:bodyPr wrap="square" lIns="0" tIns="0" rIns="0" bIns="0" rtlCol="0" anchor="ctr"/>
           <a:lstStyle/>
           <a:p>
-            <a:pPr indent="0" marL="0">
+            <a:pPr marL="0" indent="0">
               <a:buNone/>
             </a:pPr>
             <a:r>
@@ -9292,7 +8981,7 @@
             <a:endParaRPr lang="en-US" sz="1200" dirty="0"/>
           </a:p>
           <a:p>
-            <a:pPr indent="0" marL="0">
+            <a:pPr marL="0" indent="0">
               <a:buNone/>
             </a:pPr>
             <a:r>
@@ -9309,7 +8998,7 @@
             <a:endParaRPr lang="en-US" sz="1200" dirty="0"/>
           </a:p>
           <a:p>
-            <a:pPr indent="0" marL="0">
+            <a:pPr marL="0" indent="0">
               <a:buNone/>
             </a:pPr>
             <a:r>
@@ -9343,6 +9032,7 @@
         <a:solidFill>
           <a:srgbClr val="0D1B2A"/>
         </a:solidFill>
+        <a:effectLst/>
       </p:bgPr>
     </p:bg>
     <p:spTree>
@@ -9420,7 +9110,7 @@
           <a:bodyPr wrap="square" lIns="0" tIns="0" rIns="0" bIns="0" rtlCol="0" anchor="ctr"/>
           <a:lstStyle/>
           <a:p>
-            <a:pPr indent="0" marL="0">
+            <a:pPr marL="0" indent="0">
               <a:buNone/>
             </a:pPr>
             <a:r>
@@ -9459,7 +9149,7 @@
           <a:bodyPr wrap="square" lIns="0" tIns="0" rIns="0" bIns="0" rtlCol="0" anchor="ctr"/>
           <a:lstStyle/>
           <a:p>
-            <a:pPr indent="0" marL="0">
+            <a:pPr marL="0" indent="0">
               <a:buNone/>
             </a:pPr>
             <a:r>
@@ -9496,7 +9186,7 @@
           </a:solidFill>
           <a:ln/>
           <a:effectLst>
-            <a:outerShdw sx="100000" sy="100000" kx="0" ky="0" algn="bl" rotWithShape="0" blurRad="101600" dist="38100" dir="8100000">
+            <a:outerShdw blurRad="101600" dist="38100" dir="8100000" algn="bl" rotWithShape="0">
               <a:srgbClr val="000000">
                 <a:alpha val="25000"/>
               </a:srgbClr>
@@ -9545,7 +9235,7 @@
           <a:bodyPr wrap="square" lIns="0" tIns="0" rIns="0" bIns="0" rtlCol="0" anchor="ctr"/>
           <a:lstStyle/>
           <a:p>
-            <a:pPr indent="0" marL="0">
+            <a:pPr marL="0" indent="0">
               <a:buNone/>
             </a:pPr>
             <a:r>
@@ -9584,7 +9274,7 @@
           <a:bodyPr wrap="square" lIns="0" tIns="0" rIns="0" bIns="0" rtlCol="0" anchor="ctr"/>
           <a:lstStyle/>
           <a:p>
-            <a:pPr indent="0" marL="0">
+            <a:pPr marL="0" indent="0">
               <a:buNone/>
             </a:pPr>
             <a:r>
@@ -9601,7 +9291,7 @@
             <a:endParaRPr lang="en-US" sz="1200" dirty="0"/>
           </a:p>
           <a:p>
-            <a:pPr indent="0" marL="0">
+            <a:pPr marL="0" indent="0">
               <a:buNone/>
             </a:pPr>
             <a:r>
@@ -9640,7 +9330,7 @@
           <a:bodyPr wrap="square" lIns="0" tIns="0" rIns="0" bIns="0" rtlCol="0" anchor="ctr"/>
           <a:lstStyle/>
           <a:p>
-            <a:pPr indent="0" marL="0">
+            <a:pPr marL="0" indent="0">
               <a:buNone/>
             </a:pPr>
             <a:r>
@@ -9679,7 +9369,7 @@
           <a:bodyPr wrap="square" lIns="0" tIns="0" rIns="0" bIns="0" rtlCol="0" anchor="ctr"/>
           <a:lstStyle/>
           <a:p>
-            <a:pPr indent="0" marL="0">
+            <a:pPr marL="0" indent="0">
               <a:buNone/>
             </a:pPr>
             <a:r>
@@ -9696,7 +9386,7 @@
             <a:endParaRPr lang="en-US" sz="1200" dirty="0"/>
           </a:p>
           <a:p>
-            <a:pPr indent="0" marL="0">
+            <a:pPr marL="0" indent="0">
               <a:buNone/>
             </a:pPr>
             <a:r>
@@ -9713,7 +9403,7 @@
             <a:endParaRPr lang="en-US" sz="1200" dirty="0"/>
           </a:p>
           <a:p>
-            <a:pPr indent="0" marL="0">
+            <a:pPr marL="0" indent="0">
               <a:buNone/>
             </a:pPr>
             <a:r>
@@ -9750,7 +9440,7 @@
           </a:solidFill>
           <a:ln/>
           <a:effectLst>
-            <a:outerShdw sx="100000" sy="100000" kx="0" ky="0" algn="bl" rotWithShape="0" blurRad="101600" dist="38100" dir="8100000">
+            <a:outerShdw blurRad="101600" dist="38100" dir="8100000" algn="bl" rotWithShape="0">
               <a:srgbClr val="000000">
                 <a:alpha val="25000"/>
               </a:srgbClr>
@@ -9799,7 +9489,7 @@
           <a:bodyPr wrap="square" lIns="0" tIns="0" rIns="0" bIns="0" rtlCol="0" anchor="ctr"/>
           <a:lstStyle/>
           <a:p>
-            <a:pPr indent="0" marL="0">
+            <a:pPr marL="0" indent="0">
               <a:buNone/>
             </a:pPr>
             <a:r>
@@ -9838,7 +9528,7 @@
           <a:bodyPr wrap="square" lIns="0" tIns="0" rIns="0" bIns="0" rtlCol="0" anchor="ctr"/>
           <a:lstStyle/>
           <a:p>
-            <a:pPr indent="0" marL="0">
+            <a:pPr marL="0" indent="0">
               <a:buNone/>
             </a:pPr>
             <a:r>
@@ -9855,7 +9545,7 @@
             <a:endParaRPr lang="en-US" sz="1200" dirty="0"/>
           </a:p>
           <a:p>
-            <a:pPr indent="0" marL="0">
+            <a:pPr marL="0" indent="0">
               <a:buNone/>
             </a:pPr>
             <a:r>
@@ -9914,7 +9604,7 @@
           <a:bodyPr wrap="square" lIns="0" tIns="0" rIns="0" bIns="0" rtlCol="0" anchor="ctr"/>
           <a:lstStyle/>
           <a:p>
-            <a:pPr indent="0" marL="0">
+            <a:pPr marL="0" indent="0">
               <a:buNone/>
             </a:pPr>
             <a:r>
@@ -9973,7 +9663,7 @@
           <a:bodyPr wrap="square" lIns="0" tIns="0" rIns="0" bIns="0" rtlCol="0" anchor="ctr"/>
           <a:lstStyle/>
           <a:p>
-            <a:pPr indent="0" marL="0">
+            <a:pPr marL="0" indent="0">
               <a:buNone/>
             </a:pPr>
             <a:r>
@@ -10032,7 +9722,7 @@
           <a:bodyPr wrap="square" lIns="0" tIns="0" rIns="0" bIns="0" rtlCol="0" anchor="ctr"/>
           <a:lstStyle/>
           <a:p>
-            <a:pPr indent="0" marL="0">
+            <a:pPr marL="0" indent="0">
               <a:buNone/>
             </a:pPr>
             <a:r>
@@ -10091,7 +9781,7 @@
           <a:bodyPr wrap="square" lIns="0" tIns="0" rIns="0" bIns="0" rtlCol="0" anchor="ctr"/>
           <a:lstStyle/>
           <a:p>
-            <a:pPr indent="0" marL="0">
+            <a:pPr marL="0" indent="0">
               <a:buNone/>
             </a:pPr>
             <a:r>
@@ -10155,7 +9845,7 @@
           <a:bodyPr wrap="square" lIns="0" tIns="0" rIns="0" bIns="0" rtlCol="0" anchor="ctr"/>
           <a:lstStyle/>
           <a:p>
-            <a:pPr indent="0" marL="0">
+            <a:pPr marL="0" indent="0">
               <a:buNone/>
             </a:pPr>
             <a:r>
@@ -10172,7 +9862,7 @@
             <a:endParaRPr lang="en-US" sz="1200" dirty="0"/>
           </a:p>
           <a:p>
-            <a:pPr indent="0" marL="0">
+            <a:pPr marL="0" indent="0">
               <a:buNone/>
             </a:pPr>
             <a:r>
@@ -10189,7 +9879,7 @@
             <a:endParaRPr lang="en-US" sz="1200" dirty="0"/>
           </a:p>
           <a:p>
-            <a:pPr indent="0" marL="0">
+            <a:pPr marL="0" indent="0">
               <a:buNone/>
             </a:pPr>
             <a:r>
@@ -10253,7 +9943,7 @@
           <a:bodyPr wrap="square" lIns="0" tIns="0" rIns="0" bIns="0" rtlCol="0" anchor="ctr"/>
           <a:lstStyle/>
           <a:p>
-            <a:pPr indent="0" marL="0">
+            <a:pPr marL="0" indent="0">
               <a:buNone/>
             </a:pPr>
             <a:r>
@@ -10270,7 +9960,7 @@
             <a:endParaRPr lang="en-US" sz="1200" dirty="0"/>
           </a:p>
           <a:p>
-            <a:pPr indent="0" marL="0">
+            <a:pPr marL="0" indent="0">
               <a:buNone/>
             </a:pPr>
             <a:r>
@@ -10287,7 +9977,7 @@
             <a:endParaRPr lang="en-US" sz="1200" dirty="0"/>
           </a:p>
           <a:p>
-            <a:pPr indent="0" marL="0">
+            <a:pPr marL="0" indent="0">
               <a:buNone/>
             </a:pPr>
             <a:r>
@@ -10321,6 +10011,7 @@
         <a:solidFill>
           <a:srgbClr val="0D1B2A"/>
         </a:solidFill>
+        <a:effectLst/>
       </p:bgPr>
     </p:bg>
     <p:spTree>
@@ -10398,7 +10089,7 @@
           <a:bodyPr wrap="square" lIns="0" tIns="0" rIns="0" bIns="0" rtlCol="0" anchor="ctr"/>
           <a:lstStyle/>
           <a:p>
-            <a:pPr indent="0" marL="0">
+            <a:pPr marL="0" indent="0">
               <a:buNone/>
             </a:pPr>
             <a:r>
@@ -10437,7 +10128,7 @@
           <a:bodyPr wrap="square" lIns="0" tIns="0" rIns="0" bIns="0" rtlCol="0" anchor="ctr"/>
           <a:lstStyle/>
           <a:p>
-            <a:pPr indent="0" marL="0">
+            <a:pPr marL="0" indent="0">
               <a:buNone/>
             </a:pPr>
             <a:r>
@@ -10474,7 +10165,7 @@
           </a:solidFill>
           <a:ln/>
           <a:effectLst>
-            <a:outerShdw sx="100000" sy="100000" kx="0" ky="0" algn="bl" rotWithShape="0" blurRad="101600" dist="38100" dir="8100000">
+            <a:outerShdw blurRad="101600" dist="38100" dir="8100000" algn="bl" rotWithShape="0">
               <a:srgbClr val="000000">
                 <a:alpha val="25000"/>
               </a:srgbClr>
@@ -10523,7 +10214,7 @@
           <a:bodyPr wrap="square" lIns="0" tIns="0" rIns="0" bIns="0" rtlCol="0" anchor="ctr"/>
           <a:lstStyle/>
           <a:p>
-            <a:pPr indent="0" marL="0">
+            <a:pPr marL="0" indent="0">
               <a:buNone/>
             </a:pPr>
             <a:r>
@@ -10562,7 +10253,7 @@
           <a:bodyPr wrap="square" lIns="0" tIns="0" rIns="0" bIns="0" rtlCol="0" anchor="ctr"/>
           <a:lstStyle/>
           <a:p>
-            <a:pPr indent="0" marL="0">
+            <a:pPr marL="0" indent="0">
               <a:buNone/>
             </a:pPr>
             <a:r>
@@ -10601,7 +10292,7 @@
           <a:bodyPr wrap="square" lIns="0" tIns="0" rIns="0" bIns="0" rtlCol="0" anchor="ctr"/>
           <a:lstStyle/>
           <a:p>
-            <a:pPr indent="0" marL="0">
+            <a:pPr marL="0" indent="0">
               <a:buNone/>
             </a:pPr>
             <a:r>
@@ -10640,7 +10331,7 @@
           <a:bodyPr wrap="square" lIns="0" tIns="0" rIns="0" bIns="0" rtlCol="0" anchor="ctr"/>
           <a:lstStyle/>
           <a:p>
-            <a:pPr indent="0" marL="0">
+            <a:pPr marL="0" indent="0">
               <a:buNone/>
             </a:pPr>
             <a:r>
@@ -10679,7 +10370,7 @@
           <a:bodyPr wrap="square" lIns="0" tIns="0" rIns="0" bIns="0" rtlCol="0" anchor="ctr"/>
           <a:lstStyle/>
           <a:p>
-            <a:pPr indent="0" marL="0">
+            <a:pPr marL="0" indent="0">
               <a:buNone/>
             </a:pPr>
             <a:r>
@@ -10743,7 +10434,7 @@
           <a:bodyPr wrap="square" lIns="0" tIns="0" rIns="0" bIns="0" rtlCol="0" anchor="ctr"/>
           <a:lstStyle/>
           <a:p>
-            <a:pPr indent="0" marL="0">
+            <a:pPr marL="0" indent="0">
               <a:buNone/>
             </a:pPr>
             <a:r>
@@ -10760,7 +10451,7 @@
             <a:endParaRPr lang="en-US" sz="1100" dirty="0"/>
           </a:p>
           <a:p>
-            <a:pPr indent="0" marL="0">
+            <a:pPr marL="0" indent="0">
               <a:buNone/>
             </a:pPr>
             <a:r>
@@ -10797,7 +10488,7 @@
           </a:solidFill>
           <a:ln/>
           <a:effectLst>
-            <a:outerShdw sx="100000" sy="100000" kx="0" ky="0" algn="bl" rotWithShape="0" blurRad="101600" dist="38100" dir="8100000">
+            <a:outerShdw blurRad="101600" dist="38100" dir="8100000" algn="bl" rotWithShape="0">
               <a:srgbClr val="000000">
                 <a:alpha val="25000"/>
               </a:srgbClr>
@@ -10846,7 +10537,7 @@
           <a:bodyPr wrap="square" lIns="0" tIns="0" rIns="0" bIns="0" rtlCol="0" anchor="ctr"/>
           <a:lstStyle/>
           <a:p>
-            <a:pPr indent="0" marL="0">
+            <a:pPr marL="0" indent="0">
               <a:buNone/>
             </a:pPr>
             <a:r>
@@ -10885,7 +10576,7 @@
           <a:bodyPr wrap="square" lIns="0" tIns="0" rIns="0" bIns="0" rtlCol="0" anchor="ctr"/>
           <a:lstStyle/>
           <a:p>
-            <a:pPr indent="0" marL="0">
+            <a:pPr marL="0" indent="0">
               <a:buNone/>
             </a:pPr>
             <a:r>
@@ -10924,7 +10615,7 @@
           <a:bodyPr wrap="square" lIns="0" tIns="0" rIns="0" bIns="0" rtlCol="0" anchor="ctr"/>
           <a:lstStyle/>
           <a:p>
-            <a:pPr indent="0" marL="0">
+            <a:pPr marL="0" indent="0">
               <a:buNone/>
             </a:pPr>
             <a:r>
@@ -10963,7 +10654,7 @@
           <a:bodyPr wrap="square" lIns="0" tIns="0" rIns="0" bIns="0" rtlCol="0" anchor="ctr"/>
           <a:lstStyle/>
           <a:p>
-            <a:pPr indent="0" marL="0">
+            <a:pPr marL="0" indent="0">
               <a:buNone/>
             </a:pPr>
             <a:r>
@@ -11002,7 +10693,7 @@
           <a:bodyPr wrap="square" lIns="0" tIns="0" rIns="0" bIns="0" rtlCol="0" anchor="ctr"/>
           <a:lstStyle/>
           <a:p>
-            <a:pPr indent="0" marL="0">
+            <a:pPr marL="0" indent="0">
               <a:buNone/>
             </a:pPr>
             <a:r>
@@ -11066,7 +10757,7 @@
           <a:bodyPr wrap="square" lIns="0" tIns="0" rIns="0" bIns="0" rtlCol="0" anchor="ctr"/>
           <a:lstStyle/>
           <a:p>
-            <a:pPr indent="0" marL="0">
+            <a:pPr marL="0" indent="0">
               <a:buNone/>
             </a:pPr>
             <a:r>
@@ -11083,7 +10774,7 @@
             <a:endParaRPr lang="en-US" sz="1100" dirty="0"/>
           </a:p>
           <a:p>
-            <a:pPr indent="0" marL="0">
+            <a:pPr marL="0" indent="0">
               <a:buNone/>
             </a:pPr>
             <a:r>
@@ -11100,7 +10791,7 @@
             <a:endParaRPr lang="en-US" sz="1100" dirty="0"/>
           </a:p>
           <a:p>
-            <a:pPr indent="0" marL="0">
+            <a:pPr marL="0" indent="0">
               <a:buNone/>
             </a:pPr>
             <a:r>
@@ -11137,7 +10828,7 @@
           </a:solidFill>
           <a:ln/>
           <a:effectLst>
-            <a:outerShdw sx="100000" sy="100000" kx="0" ky="0" algn="bl" rotWithShape="0" blurRad="101600" dist="38100" dir="8100000">
+            <a:outerShdw blurRad="101600" dist="38100" dir="8100000" algn="bl" rotWithShape="0">
               <a:srgbClr val="000000">
                 <a:alpha val="25000"/>
               </a:srgbClr>
@@ -11186,7 +10877,7 @@
           <a:bodyPr wrap="square" lIns="0" tIns="0" rIns="0" bIns="0" rtlCol="0" anchor="ctr"/>
           <a:lstStyle/>
           <a:p>
-            <a:pPr indent="0" marL="0">
+            <a:pPr marL="0" indent="0">
               <a:buNone/>
             </a:pPr>
             <a:r>
@@ -11225,7 +10916,7 @@
           <a:bodyPr wrap="square" lIns="0" tIns="0" rIns="0" bIns="0" rtlCol="0" anchor="ctr"/>
           <a:lstStyle/>
           <a:p>
-            <a:pPr indent="0" marL="0">
+            <a:pPr marL="0" indent="0">
               <a:buNone/>
             </a:pPr>
             <a:r>
@@ -11264,7 +10955,7 @@
           <a:bodyPr wrap="square" lIns="0" tIns="0" rIns="0" bIns="0" rtlCol="0" anchor="ctr"/>
           <a:lstStyle/>
           <a:p>
-            <a:pPr indent="0" marL="0">
+            <a:pPr marL="0" indent="0">
               <a:buNone/>
             </a:pPr>
             <a:r>
@@ -11303,7 +10994,7 @@
           <a:bodyPr wrap="square" lIns="0" tIns="0" rIns="0" bIns="0" rtlCol="0" anchor="ctr"/>
           <a:lstStyle/>
           <a:p>
-            <a:pPr indent="0" marL="0">
+            <a:pPr marL="0" indent="0">
               <a:buNone/>
             </a:pPr>
             <a:r>
@@ -11342,7 +11033,7 @@
           <a:bodyPr wrap="square" lIns="0" tIns="0" rIns="0" bIns="0" rtlCol="0" anchor="ctr"/>
           <a:lstStyle/>
           <a:p>
-            <a:pPr indent="0" marL="0">
+            <a:pPr marL="0" indent="0">
               <a:buNone/>
             </a:pPr>
             <a:r>
@@ -11406,7 +11097,7 @@
           <a:bodyPr wrap="square" lIns="0" tIns="0" rIns="0" bIns="0" rtlCol="0" anchor="ctr"/>
           <a:lstStyle/>
           <a:p>
-            <a:pPr indent="0" marL="0">
+            <a:pPr marL="0" indent="0">
               <a:buNone/>
             </a:pPr>
             <a:r>
@@ -11423,7 +11114,7 @@
             <a:endParaRPr lang="en-US" sz="1100" dirty="0"/>
           </a:p>
           <a:p>
-            <a:pPr indent="0" marL="0">
+            <a:pPr marL="0" indent="0">
               <a:buNone/>
             </a:pPr>
             <a:r>
@@ -11440,7 +11131,7 @@
             <a:endParaRPr lang="en-US" sz="1100" dirty="0"/>
           </a:p>
           <a:p>
-            <a:pPr indent="0" marL="0">
+            <a:pPr marL="0" indent="0">
               <a:buNone/>
             </a:pPr>
             <a:r>
@@ -11474,6 +11165,7 @@
         <a:solidFill>
           <a:srgbClr val="0D1B2A"/>
         </a:solidFill>
+        <a:effectLst/>
       </p:bgPr>
     </p:bg>
     <p:spTree>
@@ -11551,7 +11243,7 @@
           <a:bodyPr wrap="square" lIns="0" tIns="0" rIns="0" bIns="0" rtlCol="0" anchor="ctr"/>
           <a:lstStyle/>
           <a:p>
-            <a:pPr indent="0" marL="0">
+            <a:pPr marL="0" indent="0">
               <a:buNone/>
             </a:pPr>
             <a:r>
@@ -11590,7 +11282,7 @@
           <a:bodyPr wrap="square" lIns="0" tIns="0" rIns="0" bIns="0" rtlCol="0" anchor="ctr"/>
           <a:lstStyle/>
           <a:p>
-            <a:pPr indent="0" marL="0">
+            <a:pPr marL="0" indent="0">
               <a:buNone/>
             </a:pPr>
             <a:r>
@@ -11627,7 +11319,7 @@
           </a:solidFill>
           <a:ln/>
           <a:effectLst>
-            <a:outerShdw sx="100000" sy="100000" kx="0" ky="0" algn="bl" rotWithShape="0" blurRad="101600" dist="38100" dir="8100000">
+            <a:outerShdw blurRad="101600" dist="38100" dir="8100000" algn="bl" rotWithShape="0">
               <a:srgbClr val="000000">
                 <a:alpha val="25000"/>
               </a:srgbClr>
@@ -11696,7 +11388,7 @@
           <a:bodyPr wrap="square" rtlCol="0" anchor="ctr"/>
           <a:lstStyle/>
           <a:p>
-            <a:pPr algn="ctr" indent="0" marL="0">
+            <a:pPr marL="0" indent="0" algn="ctr">
               <a:buNone/>
             </a:pPr>
             <a:r>
@@ -11735,7 +11427,7 @@
           <a:bodyPr wrap="square" lIns="0" tIns="0" rIns="0" bIns="0" rtlCol="0" anchor="ctr"/>
           <a:lstStyle/>
           <a:p>
-            <a:pPr indent="0" marL="0">
+            <a:pPr marL="0" indent="0">
               <a:buNone/>
             </a:pPr>
             <a:r>
@@ -11774,7 +11466,7 @@
           <a:bodyPr wrap="square" lIns="0" tIns="0" rIns="0" bIns="0" rtlCol="0" anchor="ctr"/>
           <a:lstStyle/>
           <a:p>
-            <a:pPr indent="0" marL="0">
+            <a:pPr marL="0" indent="0">
               <a:buNone/>
             </a:pPr>
             <a:r>
@@ -11811,7 +11503,7 @@
           </a:solidFill>
           <a:ln/>
           <a:effectLst>
-            <a:outerShdw sx="100000" sy="100000" kx="0" ky="0" algn="bl" rotWithShape="0" blurRad="101600" dist="38100" dir="8100000">
+            <a:outerShdw blurRad="101600" dist="38100" dir="8100000" algn="bl" rotWithShape="0">
               <a:srgbClr val="000000">
                 <a:alpha val="25000"/>
               </a:srgbClr>
@@ -11880,7 +11572,7 @@
           <a:bodyPr wrap="square" rtlCol="0" anchor="ctr"/>
           <a:lstStyle/>
           <a:p>
-            <a:pPr algn="ctr" indent="0" marL="0">
+            <a:pPr marL="0" indent="0" algn="ctr">
               <a:buNone/>
             </a:pPr>
             <a:r>
@@ -11919,7 +11611,7 @@
           <a:bodyPr wrap="square" lIns="0" tIns="0" rIns="0" bIns="0" rtlCol="0" anchor="ctr"/>
           <a:lstStyle/>
           <a:p>
-            <a:pPr indent="0" marL="0">
+            <a:pPr marL="0" indent="0">
               <a:buNone/>
             </a:pPr>
             <a:r>
@@ -11958,7 +11650,7 @@
           <a:bodyPr wrap="square" lIns="0" tIns="0" rIns="0" bIns="0" rtlCol="0" anchor="ctr"/>
           <a:lstStyle/>
           <a:p>
-            <a:pPr indent="0" marL="0">
+            <a:pPr marL="0" indent="0">
               <a:buNone/>
             </a:pPr>
             <a:r>
@@ -11995,7 +11687,7 @@
           </a:solidFill>
           <a:ln/>
           <a:effectLst>
-            <a:outerShdw sx="100000" sy="100000" kx="0" ky="0" algn="bl" rotWithShape="0" blurRad="101600" dist="38100" dir="8100000">
+            <a:outerShdw blurRad="101600" dist="38100" dir="8100000" algn="bl" rotWithShape="0">
               <a:srgbClr val="000000">
                 <a:alpha val="25000"/>
               </a:srgbClr>
@@ -12064,7 +11756,7 @@
           <a:bodyPr wrap="square" rtlCol="0" anchor="ctr"/>
           <a:lstStyle/>
           <a:p>
-            <a:pPr algn="ctr" indent="0" marL="0">
+            <a:pPr marL="0" indent="0" algn="ctr">
               <a:buNone/>
             </a:pPr>
             <a:r>
@@ -12103,7 +11795,7 @@
           <a:bodyPr wrap="square" lIns="0" tIns="0" rIns="0" bIns="0" rtlCol="0" anchor="ctr"/>
           <a:lstStyle/>
           <a:p>
-            <a:pPr indent="0" marL="0">
+            <a:pPr marL="0" indent="0">
               <a:buNone/>
             </a:pPr>
             <a:r>
@@ -12142,7 +11834,7 @@
           <a:bodyPr wrap="square" lIns="0" tIns="0" rIns="0" bIns="0" rtlCol="0" anchor="ctr"/>
           <a:lstStyle/>
           <a:p>
-            <a:pPr indent="0" marL="0">
+            <a:pPr marL="0" indent="0">
               <a:buNone/>
             </a:pPr>
             <a:r>
@@ -12179,7 +11871,7 @@
           </a:solidFill>
           <a:ln/>
           <a:effectLst>
-            <a:outerShdw sx="100000" sy="100000" kx="0" ky="0" algn="bl" rotWithShape="0" blurRad="101600" dist="38100" dir="8100000">
+            <a:outerShdw blurRad="101600" dist="38100" dir="8100000" algn="bl" rotWithShape="0">
               <a:srgbClr val="000000">
                 <a:alpha val="25000"/>
               </a:srgbClr>
@@ -12248,7 +11940,7 @@
           <a:bodyPr wrap="square" rtlCol="0" anchor="ctr"/>
           <a:lstStyle/>
           <a:p>
-            <a:pPr algn="ctr" indent="0" marL="0">
+            <a:pPr marL="0" indent="0" algn="ctr">
               <a:buNone/>
             </a:pPr>
             <a:r>
@@ -12287,7 +11979,7 @@
           <a:bodyPr wrap="square" lIns="0" tIns="0" rIns="0" bIns="0" rtlCol="0" anchor="ctr"/>
           <a:lstStyle/>
           <a:p>
-            <a:pPr indent="0" marL="0">
+            <a:pPr marL="0" indent="0">
               <a:buNone/>
             </a:pPr>
             <a:r>
@@ -12326,7 +12018,7 @@
           <a:bodyPr wrap="square" lIns="0" tIns="0" rIns="0" bIns="0" rtlCol="0" anchor="ctr"/>
           <a:lstStyle/>
           <a:p>
-            <a:pPr indent="0" marL="0">
+            <a:pPr marL="0" indent="0">
               <a:buNone/>
             </a:pPr>
             <a:r>
@@ -12363,7 +12055,7 @@
           </a:solidFill>
           <a:ln/>
           <a:effectLst>
-            <a:outerShdw sx="100000" sy="100000" kx="0" ky="0" algn="bl" rotWithShape="0" blurRad="101600" dist="38100" dir="8100000">
+            <a:outerShdw blurRad="101600" dist="38100" dir="8100000" algn="bl" rotWithShape="0">
               <a:srgbClr val="000000">
                 <a:alpha val="25000"/>
               </a:srgbClr>
@@ -12432,7 +12124,7 @@
           <a:bodyPr wrap="square" rtlCol="0" anchor="ctr"/>
           <a:lstStyle/>
           <a:p>
-            <a:pPr algn="ctr" indent="0" marL="0">
+            <a:pPr marL="0" indent="0" algn="ctr">
               <a:buNone/>
             </a:pPr>
             <a:r>
@@ -12471,7 +12163,7 @@
           <a:bodyPr wrap="square" lIns="0" tIns="0" rIns="0" bIns="0" rtlCol="0" anchor="ctr"/>
           <a:lstStyle/>
           <a:p>
-            <a:pPr indent="0" marL="0">
+            <a:pPr marL="0" indent="0">
               <a:buNone/>
             </a:pPr>
             <a:r>
@@ -12510,7 +12202,7 @@
           <a:bodyPr wrap="square" lIns="0" tIns="0" rIns="0" bIns="0" rtlCol="0" anchor="ctr"/>
           <a:lstStyle/>
           <a:p>
-            <a:pPr indent="0" marL="0">
+            <a:pPr marL="0" indent="0">
               <a:buNone/>
             </a:pPr>
             <a:r>
@@ -12544,6 +12236,7 @@
         <a:solidFill>
           <a:srgbClr val="0D1B2A"/>
         </a:solidFill>
+        <a:effectLst/>
       </p:bgPr>
     </p:bg>
     <p:spTree>
@@ -12621,7 +12314,7 @@
           <a:bodyPr wrap="square" lIns="0" tIns="0" rIns="0" bIns="0" rtlCol="0" anchor="ctr"/>
           <a:lstStyle/>
           <a:p>
-            <a:pPr indent="0" marL="0">
+            <a:pPr marL="0" indent="0">
               <a:buNone/>
             </a:pPr>
             <a:r>
@@ -12660,7 +12353,7 @@
           <a:bodyPr wrap="square" lIns="0" tIns="0" rIns="0" bIns="0" rtlCol="0" anchor="ctr"/>
           <a:lstStyle/>
           <a:p>
-            <a:pPr indent="0" marL="0">
+            <a:pPr marL="0" indent="0">
               <a:buNone/>
             </a:pPr>
             <a:r>
@@ -12697,7 +12390,7 @@
           </a:solidFill>
           <a:ln/>
           <a:effectLst>
-            <a:outerShdw sx="100000" sy="100000" kx="0" ky="0" algn="bl" rotWithShape="0" blurRad="101600" dist="38100" dir="8100000">
+            <a:outerShdw blurRad="101600" dist="38100" dir="8100000" algn="bl" rotWithShape="0">
               <a:srgbClr val="000000">
                 <a:alpha val="25000"/>
               </a:srgbClr>
@@ -12746,7 +12439,7 @@
           <a:bodyPr wrap="square" lIns="0" tIns="0" rIns="0" bIns="0" rtlCol="0" anchor="ctr"/>
           <a:lstStyle/>
           <a:p>
-            <a:pPr indent="0" marL="0">
+            <a:pPr marL="0" indent="0">
               <a:buNone/>
             </a:pPr>
             <a:r>
@@ -12785,7 +12478,7 @@
           <a:bodyPr wrap="square" lIns="0" tIns="0" rIns="0" bIns="0" rtlCol="0" anchor="ctr"/>
           <a:lstStyle/>
           <a:p>
-            <a:pPr indent="0" marL="0">
+            <a:pPr marL="0" indent="0">
               <a:buNone/>
             </a:pPr>
             <a:r>
@@ -12802,7 +12495,7 @@
             <a:endParaRPr lang="en-US" sz="1100" dirty="0"/>
           </a:p>
           <a:p>
-            <a:pPr indent="0" marL="0">
+            <a:pPr marL="0" indent="0">
               <a:buNone/>
             </a:pPr>
             <a:r>
@@ -12861,7 +12554,7 @@
           <a:bodyPr wrap="square" lIns="0" tIns="0" rIns="0" bIns="0" rtlCol="0" anchor="ctr"/>
           <a:lstStyle/>
           <a:p>
-            <a:pPr indent="0" marL="0">
+            <a:pPr marL="0" indent="0">
               <a:buNone/>
             </a:pPr>
             <a:r>
@@ -12898,7 +12591,7 @@
           </a:solidFill>
           <a:ln/>
           <a:effectLst>
-            <a:outerShdw sx="100000" sy="100000" kx="0" ky="0" algn="bl" rotWithShape="0" blurRad="101600" dist="38100" dir="8100000">
+            <a:outerShdw blurRad="101600" dist="38100" dir="8100000" algn="bl" rotWithShape="0">
               <a:srgbClr val="000000">
                 <a:alpha val="25000"/>
               </a:srgbClr>
@@ -12947,7 +12640,7 @@
           <a:bodyPr wrap="square" lIns="0" tIns="0" rIns="0" bIns="0" rtlCol="0" anchor="ctr"/>
           <a:lstStyle/>
           <a:p>
-            <a:pPr indent="0" marL="0">
+            <a:pPr marL="0" indent="0">
               <a:buNone/>
             </a:pPr>
             <a:r>
@@ -12986,7 +12679,7 @@
           <a:bodyPr wrap="square" lIns="0" tIns="0" rIns="0" bIns="0" rtlCol="0" anchor="ctr"/>
           <a:lstStyle/>
           <a:p>
-            <a:pPr indent="0" marL="0">
+            <a:pPr marL="0" indent="0">
               <a:buNone/>
             </a:pPr>
             <a:r>
@@ -13003,7 +12696,7 @@
             <a:endParaRPr lang="en-US" sz="1100" dirty="0"/>
           </a:p>
           <a:p>
-            <a:pPr indent="0" marL="0">
+            <a:pPr marL="0" indent="0">
               <a:buNone/>
             </a:pPr>
             <a:r>
@@ -13062,7 +12755,7 @@
           <a:bodyPr wrap="square" lIns="0" tIns="0" rIns="0" bIns="0" rtlCol="0" anchor="ctr"/>
           <a:lstStyle/>
           <a:p>
-            <a:pPr indent="0" marL="0">
+            <a:pPr marL="0" indent="0">
               <a:buNone/>
             </a:pPr>
             <a:r>
@@ -13099,7 +12792,7 @@
           </a:solidFill>
           <a:ln/>
           <a:effectLst>
-            <a:outerShdw sx="100000" sy="100000" kx="0" ky="0" algn="bl" rotWithShape="0" blurRad="101600" dist="38100" dir="8100000">
+            <a:outerShdw blurRad="101600" dist="38100" dir="8100000" algn="bl" rotWithShape="0">
               <a:srgbClr val="000000">
                 <a:alpha val="25000"/>
               </a:srgbClr>
@@ -13148,7 +12841,7 @@
           <a:bodyPr wrap="square" lIns="0" tIns="0" rIns="0" bIns="0" rtlCol="0" anchor="ctr"/>
           <a:lstStyle/>
           <a:p>
-            <a:pPr indent="0" marL="0">
+            <a:pPr marL="0" indent="0">
               <a:buNone/>
             </a:pPr>
             <a:r>
@@ -13187,7 +12880,7 @@
           <a:bodyPr wrap="square" lIns="0" tIns="0" rIns="0" bIns="0" rtlCol="0" anchor="ctr"/>
           <a:lstStyle/>
           <a:p>
-            <a:pPr indent="0" marL="0">
+            <a:pPr marL="0" indent="0">
               <a:buNone/>
             </a:pPr>
             <a:r>
@@ -13204,7 +12897,7 @@
             <a:endParaRPr lang="en-US" sz="1100" dirty="0"/>
           </a:p>
           <a:p>
-            <a:pPr indent="0" marL="0">
+            <a:pPr marL="0" indent="0">
               <a:buNone/>
             </a:pPr>
             <a:r>
@@ -13263,7 +12956,7 @@
           <a:bodyPr wrap="square" lIns="0" tIns="0" rIns="0" bIns="0" rtlCol="0" anchor="ctr"/>
           <a:lstStyle/>
           <a:p>
-            <a:pPr indent="0" marL="0">
+            <a:pPr marL="0" indent="0">
               <a:buNone/>
             </a:pPr>
             <a:r>
@@ -13300,7 +12993,7 @@
           </a:solidFill>
           <a:ln/>
           <a:effectLst>
-            <a:outerShdw sx="100000" sy="100000" kx="0" ky="0" algn="bl" rotWithShape="0" blurRad="101600" dist="38100" dir="8100000">
+            <a:outerShdw blurRad="101600" dist="38100" dir="8100000" algn="bl" rotWithShape="0">
               <a:srgbClr val="000000">
                 <a:alpha val="25000"/>
               </a:srgbClr>
@@ -13349,7 +13042,7 @@
           <a:bodyPr wrap="square" lIns="0" tIns="0" rIns="0" bIns="0" rtlCol="0" anchor="ctr"/>
           <a:lstStyle/>
           <a:p>
-            <a:pPr indent="0" marL="0">
+            <a:pPr marL="0" indent="0">
               <a:buNone/>
             </a:pPr>
             <a:r>
@@ -13388,7 +13081,7 @@
           <a:bodyPr wrap="square" lIns="0" tIns="0" rIns="0" bIns="0" rtlCol="0" anchor="ctr"/>
           <a:lstStyle/>
           <a:p>
-            <a:pPr indent="0" marL="0">
+            <a:pPr marL="0" indent="0">
               <a:buNone/>
             </a:pPr>
             <a:r>
@@ -13405,7 +13098,7 @@
             <a:endParaRPr lang="en-US" sz="1100" dirty="0"/>
           </a:p>
           <a:p>
-            <a:pPr indent="0" marL="0">
+            <a:pPr marL="0" indent="0">
               <a:buNone/>
             </a:pPr>
             <a:r>
@@ -13464,7 +13157,7 @@
           <a:bodyPr wrap="square" lIns="0" tIns="0" rIns="0" bIns="0" rtlCol="0" anchor="ctr"/>
           <a:lstStyle/>
           <a:p>
-            <a:pPr indent="0" marL="0">
+            <a:pPr marL="0" indent="0">
               <a:buNone/>
             </a:pPr>
             <a:r>
@@ -13481,7 +13174,7 @@
             <a:endParaRPr lang="en-US" sz="1100" dirty="0"/>
           </a:p>
           <a:p>
-            <a:pPr indent="0" marL="0">
+            <a:pPr marL="0" indent="0">
               <a:buNone/>
             </a:pPr>
             <a:r>
@@ -13518,7 +13211,7 @@
           </a:solidFill>
           <a:ln/>
           <a:effectLst>
-            <a:outerShdw sx="100000" sy="100000" kx="0" ky="0" algn="bl" rotWithShape="0" blurRad="101600" dist="38100" dir="8100000">
+            <a:outerShdw blurRad="101600" dist="38100" dir="8100000" algn="bl" rotWithShape="0">
               <a:srgbClr val="000000">
                 <a:alpha val="25000"/>
               </a:srgbClr>
@@ -13567,7 +13260,7 @@
           <a:bodyPr wrap="square" lIns="0" tIns="0" rIns="0" bIns="0" rtlCol="0" anchor="ctr"/>
           <a:lstStyle/>
           <a:p>
-            <a:pPr indent="0" marL="0">
+            <a:pPr marL="0" indent="0">
               <a:buNone/>
             </a:pPr>
             <a:r>
@@ -13606,7 +13299,7 @@
           <a:bodyPr wrap="square" lIns="0" tIns="0" rIns="0" bIns="0" rtlCol="0" anchor="ctr"/>
           <a:lstStyle/>
           <a:p>
-            <a:pPr indent="0" marL="0">
+            <a:pPr marL="0" indent="0">
               <a:buNone/>
             </a:pPr>
             <a:r>
@@ -13623,7 +13316,7 @@
             <a:endParaRPr lang="en-US" sz="1100" dirty="0"/>
           </a:p>
           <a:p>
-            <a:pPr indent="0" marL="0">
+            <a:pPr marL="0" indent="0">
               <a:buNone/>
             </a:pPr>
             <a:r>
@@ -13682,7 +13375,7 @@
           <a:bodyPr wrap="square" lIns="0" tIns="0" rIns="0" bIns="0" rtlCol="0" anchor="ctr"/>
           <a:lstStyle/>
           <a:p>
-            <a:pPr indent="0" marL="0">
+            <a:pPr marL="0" indent="0">
               <a:buNone/>
             </a:pPr>
             <a:r>
@@ -13699,7 +13392,7 @@
             <a:endParaRPr lang="en-US" sz="1100" dirty="0"/>
           </a:p>
           <a:p>
-            <a:pPr indent="0" marL="0">
+            <a:pPr marL="0" indent="0">
               <a:buNone/>
             </a:pPr>
             <a:r>
@@ -13736,7 +13429,7 @@
           </a:solidFill>
           <a:ln/>
           <a:effectLst>
-            <a:outerShdw sx="100000" sy="100000" kx="0" ky="0" algn="bl" rotWithShape="0" blurRad="101600" dist="38100" dir="8100000">
+            <a:outerShdw blurRad="101600" dist="38100" dir="8100000" algn="bl" rotWithShape="0">
               <a:srgbClr val="000000">
                 <a:alpha val="25000"/>
               </a:srgbClr>
@@ -13785,7 +13478,7 @@
           <a:bodyPr wrap="square" lIns="0" tIns="0" rIns="0" bIns="0" rtlCol="0" anchor="ctr"/>
           <a:lstStyle/>
           <a:p>
-            <a:pPr indent="0" marL="0">
+            <a:pPr marL="0" indent="0">
               <a:buNone/>
             </a:pPr>
             <a:r>
@@ -13824,7 +13517,7 @@
           <a:bodyPr wrap="square" lIns="0" tIns="0" rIns="0" bIns="0" rtlCol="0" anchor="ctr"/>
           <a:lstStyle/>
           <a:p>
-            <a:pPr indent="0" marL="0">
+            <a:pPr marL="0" indent="0">
               <a:buNone/>
             </a:pPr>
             <a:r>
@@ -13863,7 +13556,7 @@
           <a:bodyPr wrap="square" lIns="0" tIns="0" rIns="0" bIns="0" rtlCol="0" anchor="ctr"/>
           <a:lstStyle/>
           <a:p>
-            <a:pPr indent="0" marL="0">
+            <a:pPr marL="0" indent="0">
               <a:buNone/>
             </a:pPr>
             <a:r>
@@ -13902,7 +13595,7 @@
           <a:bodyPr wrap="square" lIns="0" tIns="0" rIns="0" bIns="0" rtlCol="0" anchor="ctr"/>
           <a:lstStyle/>
           <a:p>
-            <a:pPr indent="0" marL="0">
+            <a:pPr marL="0" indent="0">
               <a:buNone/>
             </a:pPr>
             <a:r>
@@ -13941,7 +13634,7 @@
           <a:bodyPr wrap="square" lIns="0" tIns="0" rIns="0" bIns="0" rtlCol="0" anchor="ctr"/>
           <a:lstStyle/>
           <a:p>
-            <a:pPr indent="0" marL="0">
+            <a:pPr marL="0" indent="0">
               <a:buNone/>
             </a:pPr>
             <a:r>
@@ -13980,7 +13673,7 @@
           <a:bodyPr wrap="square" lIns="0" tIns="0" rIns="0" bIns="0" rtlCol="0" anchor="ctr"/>
           <a:lstStyle/>
           <a:p>
-            <a:pPr indent="0" marL="0">
+            <a:pPr marL="0" indent="0">
               <a:buNone/>
             </a:pPr>
             <a:r>
@@ -14014,6 +13707,7 @@
         <a:solidFill>
           <a:srgbClr val="0D1B2A"/>
         </a:solidFill>
+        <a:effectLst/>
       </p:bgPr>
     </p:bg>
     <p:spTree>
@@ -14091,7 +13785,7 @@
           <a:bodyPr wrap="square" lIns="0" tIns="0" rIns="0" bIns="0" rtlCol="0" anchor="ctr"/>
           <a:lstStyle/>
           <a:p>
-            <a:pPr indent="0" marL="0">
+            <a:pPr marL="0" indent="0">
               <a:buNone/>
             </a:pPr>
             <a:r>
@@ -14130,7 +13824,7 @@
           <a:bodyPr wrap="square" lIns="0" tIns="0" rIns="0" bIns="0" rtlCol="0" anchor="ctr"/>
           <a:lstStyle/>
           <a:p>
-            <a:pPr indent="0" marL="0">
+            <a:pPr marL="0" indent="0">
               <a:buNone/>
             </a:pPr>
             <a:r>
@@ -14167,7 +13861,7 @@
           </a:solidFill>
           <a:ln/>
           <a:effectLst>
-            <a:outerShdw sx="100000" sy="100000" kx="0" ky="0" algn="bl" rotWithShape="0" blurRad="101600" dist="38100" dir="8100000">
+            <a:outerShdw blurRad="101600" dist="38100" dir="8100000" algn="bl" rotWithShape="0">
               <a:srgbClr val="000000">
                 <a:alpha val="25000"/>
               </a:srgbClr>
@@ -14236,7 +13930,7 @@
           <a:bodyPr wrap="square" rtlCol="0" anchor="ctr"/>
           <a:lstStyle/>
           <a:p>
-            <a:pPr algn="ctr" indent="0" marL="0">
+            <a:pPr marL="0" indent="0" algn="ctr">
               <a:buNone/>
             </a:pPr>
             <a:r>
@@ -14275,7 +13969,7 @@
           <a:bodyPr wrap="square" lIns="0" tIns="0" rIns="0" bIns="0" rtlCol="0" anchor="ctr"/>
           <a:lstStyle/>
           <a:p>
-            <a:pPr indent="0" marL="0">
+            <a:pPr marL="0" indent="0">
               <a:buNone/>
             </a:pPr>
             <a:r>
@@ -14314,7 +14008,7 @@
           <a:bodyPr wrap="square" lIns="0" tIns="0" rIns="0" bIns="0" rtlCol="0" anchor="ctr"/>
           <a:lstStyle/>
           <a:p>
-            <a:pPr indent="0" marL="0">
+            <a:pPr marL="0" indent="0">
               <a:buNone/>
             </a:pPr>
             <a:r>
@@ -14351,7 +14045,7 @@
           </a:solidFill>
           <a:ln/>
           <a:effectLst>
-            <a:outerShdw sx="100000" sy="100000" kx="0" ky="0" algn="bl" rotWithShape="0" blurRad="101600" dist="38100" dir="8100000">
+            <a:outerShdw blurRad="101600" dist="38100" dir="8100000" algn="bl" rotWithShape="0">
               <a:srgbClr val="000000">
                 <a:alpha val="25000"/>
               </a:srgbClr>
@@ -14420,7 +14114,7 @@
           <a:bodyPr wrap="square" rtlCol="0" anchor="ctr"/>
           <a:lstStyle/>
           <a:p>
-            <a:pPr algn="ctr" indent="0" marL="0">
+            <a:pPr marL="0" indent="0" algn="ctr">
               <a:buNone/>
             </a:pPr>
             <a:r>
@@ -14459,7 +14153,7 @@
           <a:bodyPr wrap="square" lIns="0" tIns="0" rIns="0" bIns="0" rtlCol="0" anchor="ctr"/>
           <a:lstStyle/>
           <a:p>
-            <a:pPr indent="0" marL="0">
+            <a:pPr marL="0" indent="0">
               <a:buNone/>
             </a:pPr>
             <a:r>
@@ -14498,7 +14192,7 @@
           <a:bodyPr wrap="square" lIns="0" tIns="0" rIns="0" bIns="0" rtlCol="0" anchor="ctr"/>
           <a:lstStyle/>
           <a:p>
-            <a:pPr indent="0" marL="0">
+            <a:pPr marL="0" indent="0">
               <a:buNone/>
             </a:pPr>
             <a:r>
@@ -14535,7 +14229,7 @@
           </a:solidFill>
           <a:ln/>
           <a:effectLst>
-            <a:outerShdw sx="100000" sy="100000" kx="0" ky="0" algn="bl" rotWithShape="0" blurRad="101600" dist="38100" dir="8100000">
+            <a:outerShdw blurRad="101600" dist="38100" dir="8100000" algn="bl" rotWithShape="0">
               <a:srgbClr val="000000">
                 <a:alpha val="25000"/>
               </a:srgbClr>
@@ -14604,7 +14298,7 @@
           <a:bodyPr wrap="square" rtlCol="0" anchor="ctr"/>
           <a:lstStyle/>
           <a:p>
-            <a:pPr algn="ctr" indent="0" marL="0">
+            <a:pPr marL="0" indent="0" algn="ctr">
               <a:buNone/>
             </a:pPr>
             <a:r>
@@ -14643,7 +14337,7 @@
           <a:bodyPr wrap="square" lIns="0" tIns="0" rIns="0" bIns="0" rtlCol="0" anchor="ctr"/>
           <a:lstStyle/>
           <a:p>
-            <a:pPr indent="0" marL="0">
+            <a:pPr marL="0" indent="0">
               <a:buNone/>
             </a:pPr>
             <a:r>
@@ -14682,7 +14376,7 @@
           <a:bodyPr wrap="square" lIns="0" tIns="0" rIns="0" bIns="0" rtlCol="0" anchor="ctr"/>
           <a:lstStyle/>
           <a:p>
-            <a:pPr indent="0" marL="0">
+            <a:pPr marL="0" indent="0">
               <a:buNone/>
             </a:pPr>
             <a:r>
@@ -14719,7 +14413,7 @@
           </a:solidFill>
           <a:ln/>
           <a:effectLst>
-            <a:outerShdw sx="100000" sy="100000" kx="0" ky="0" algn="bl" rotWithShape="0" blurRad="101600" dist="38100" dir="8100000">
+            <a:outerShdw blurRad="101600" dist="38100" dir="8100000" algn="bl" rotWithShape="0">
               <a:srgbClr val="000000">
                 <a:alpha val="25000"/>
               </a:srgbClr>
@@ -14788,7 +14482,7 @@
           <a:bodyPr wrap="square" rtlCol="0" anchor="ctr"/>
           <a:lstStyle/>
           <a:p>
-            <a:pPr algn="ctr" indent="0" marL="0">
+            <a:pPr marL="0" indent="0" algn="ctr">
               <a:buNone/>
             </a:pPr>
             <a:r>
@@ -14827,7 +14521,7 @@
           <a:bodyPr wrap="square" lIns="0" tIns="0" rIns="0" bIns="0" rtlCol="0" anchor="ctr"/>
           <a:lstStyle/>
           <a:p>
-            <a:pPr indent="0" marL="0">
+            <a:pPr marL="0" indent="0">
               <a:buNone/>
             </a:pPr>
             <a:r>
@@ -14866,7 +14560,7 @@
           <a:bodyPr wrap="square" lIns="0" tIns="0" rIns="0" bIns="0" rtlCol="0" anchor="ctr"/>
           <a:lstStyle/>
           <a:p>
-            <a:pPr indent="0" marL="0">
+            <a:pPr marL="0" indent="0">
               <a:buNone/>
             </a:pPr>
             <a:r>
@@ -14903,7 +14597,7 @@
           </a:solidFill>
           <a:ln/>
           <a:effectLst>
-            <a:outerShdw sx="100000" sy="100000" kx="0" ky="0" algn="bl" rotWithShape="0" blurRad="101600" dist="38100" dir="8100000">
+            <a:outerShdw blurRad="101600" dist="38100" dir="8100000" algn="bl" rotWithShape="0">
               <a:srgbClr val="000000">
                 <a:alpha val="25000"/>
               </a:srgbClr>
@@ -14972,7 +14666,7 @@
           <a:bodyPr wrap="square" rtlCol="0" anchor="ctr"/>
           <a:lstStyle/>
           <a:p>
-            <a:pPr algn="ctr" indent="0" marL="0">
+            <a:pPr marL="0" indent="0" algn="ctr">
               <a:buNone/>
             </a:pPr>
             <a:r>
@@ -15011,7 +14705,7 @@
           <a:bodyPr wrap="square" lIns="0" tIns="0" rIns="0" bIns="0" rtlCol="0" anchor="ctr"/>
           <a:lstStyle/>
           <a:p>
-            <a:pPr indent="0" marL="0">
+            <a:pPr marL="0" indent="0">
               <a:buNone/>
             </a:pPr>
             <a:r>
@@ -15050,7 +14744,7 @@
           <a:bodyPr wrap="square" lIns="0" tIns="0" rIns="0" bIns="0" rtlCol="0" anchor="ctr"/>
           <a:lstStyle/>
           <a:p>
-            <a:pPr indent="0" marL="0">
+            <a:pPr marL="0" indent="0">
               <a:buNone/>
             </a:pPr>
             <a:r>
@@ -15369,4 +15063,299 @@
     </a:ext>
   </a:extLst>
 </a:theme>
+</file>
+
+<file path=ppt/theme/theme2.xml><?xml version="1.0" encoding="utf-8"?>
+<a:theme xmlns:a="http://schemas.openxmlformats.org/drawingml/2006/main" name="Office Theme">
+  <a:themeElements>
+    <a:clrScheme name="Office">
+      <a:dk1>
+        <a:sysClr val="windowText" lastClr="000000"/>
+      </a:dk1>
+      <a:lt1>
+        <a:sysClr val="window" lastClr="FFFFFF"/>
+      </a:lt1>
+      <a:dk2>
+        <a:srgbClr val="44546A"/>
+      </a:dk2>
+      <a:lt2>
+        <a:srgbClr val="E7E6E6"/>
+      </a:lt2>
+      <a:accent1>
+        <a:srgbClr val="4472C4"/>
+      </a:accent1>
+      <a:accent2>
+        <a:srgbClr val="ED7D31"/>
+      </a:accent2>
+      <a:accent3>
+        <a:srgbClr val="A5A5A5"/>
+      </a:accent3>
+      <a:accent4>
+        <a:srgbClr val="FFC000"/>
+      </a:accent4>
+      <a:accent5>
+        <a:srgbClr val="5B9BD5"/>
+      </a:accent5>
+      <a:accent6>
+        <a:srgbClr val="70AD47"/>
+      </a:accent6>
+      <a:hlink>
+        <a:srgbClr val="0563C1"/>
+      </a:hlink>
+      <a:folHlink>
+        <a:srgbClr val="954F72"/>
+      </a:folHlink>
+    </a:clrScheme>
+    <a:fontScheme name="Office">
+      <a:majorFont>
+        <a:latin typeface="Calibri Light" panose="020F0302020204030204"/>
+        <a:ea typeface=""/>
+        <a:cs typeface=""/>
+        <a:font script="Jpan" typeface="游ゴシック Light"/>
+        <a:font script="Hang" typeface="맑은 고딕"/>
+        <a:font script="Hans" typeface="等线 Light"/>
+        <a:font script="Hant" typeface="新細明體"/>
+        <a:font script="Arab" typeface="Times New Roman"/>
+        <a:font script="Hebr" typeface="Times New Roman"/>
+        <a:font script="Thai" typeface="Angsana New"/>
+        <a:font script="Ethi" typeface="Nyala"/>
+        <a:font script="Beng" typeface="Vrinda"/>
+        <a:font script="Gujr" typeface="Shruti"/>
+        <a:font script="Khmr" typeface="MoolBoran"/>
+        <a:font script="Knda" typeface="Tunga"/>
+        <a:font script="Guru" typeface="Raavi"/>
+        <a:font script="Cans" typeface="Euphemia"/>
+        <a:font script="Cher" typeface="Plantagenet Cherokee"/>
+        <a:font script="Yiii" typeface="Microsoft Yi Baiti"/>
+        <a:font script="Tibt" typeface="Microsoft Himalaya"/>
+        <a:font script="Thaa" typeface="MV Boli"/>
+        <a:font script="Deva" typeface="Mangal"/>
+        <a:font script="Telu" typeface="Gautami"/>
+        <a:font script="Taml" typeface="Latha"/>
+        <a:font script="Syrc" typeface="Estrangelo Edessa"/>
+        <a:font script="Orya" typeface="Kalinga"/>
+        <a:font script="Mlym" typeface="Kartika"/>
+        <a:font script="Laoo" typeface="DokChampa"/>
+        <a:font script="Sinh" typeface="Iskoola Pota"/>
+        <a:font script="Mong" typeface="Mongolian Baiti"/>
+        <a:font script="Viet" typeface="Times New Roman"/>
+        <a:font script="Uigh" typeface="Microsoft Uighur"/>
+        <a:font script="Geor" typeface="Sylfaen"/>
+        <a:font script="Armn" typeface="Arial"/>
+        <a:font script="Bugi" typeface="Leelawadee UI"/>
+        <a:font script="Bopo" typeface="Microsoft JhengHei"/>
+        <a:font script="Java" typeface="Javanese Text"/>
+        <a:font script="Lisu" typeface="Segoe UI"/>
+        <a:font script="Mymr" typeface="Myanmar Text"/>
+        <a:font script="Nkoo" typeface="Ebrima"/>
+        <a:font script="Olck" typeface="Nirmala UI"/>
+        <a:font script="Osma" typeface="Ebrima"/>
+        <a:font script="Phag" typeface="Phagspa"/>
+        <a:font script="Syrn" typeface="Estrangelo Edessa"/>
+        <a:font script="Syrj" typeface="Estrangelo Edessa"/>
+        <a:font script="Syre" typeface="Estrangelo Edessa"/>
+        <a:font script="Sora" typeface="Nirmala UI"/>
+        <a:font script="Tale" typeface="Microsoft Tai Le"/>
+        <a:font script="Talu" typeface="Microsoft New Tai Lue"/>
+        <a:font script="Tfng" typeface="Ebrima"/>
+      </a:majorFont>
+      <a:minorFont>
+        <a:latin typeface="Calibri" panose="020F0502020204030204"/>
+        <a:ea typeface=""/>
+        <a:cs typeface=""/>
+        <a:font script="Jpan" typeface="游ゴシック"/>
+        <a:font script="Hang" typeface="맑은 고딕"/>
+        <a:font script="Hans" typeface="等线"/>
+        <a:font script="Hant" typeface="新細明體"/>
+        <a:font script="Arab" typeface="Arial"/>
+        <a:font script="Hebr" typeface="Arial"/>
+        <a:font script="Thai" typeface="Cordia New"/>
+        <a:font script="Ethi" typeface="Nyala"/>
+        <a:font script="Beng" typeface="Vrinda"/>
+        <a:font script="Gujr" typeface="Shruti"/>
+        <a:font script="Khmr" typeface="DaunPenh"/>
+        <a:font script="Knda" typeface="Tunga"/>
+        <a:font script="Guru" typeface="Raavi"/>
+        <a:font script="Cans" typeface="Euphemia"/>
+        <a:font script="Cher" typeface="Plantagenet Cherokee"/>
+        <a:font script="Yiii" typeface="Microsoft Yi Baiti"/>
+        <a:font script="Tibt" typeface="Microsoft Himalaya"/>
+        <a:font script="Thaa" typeface="MV Boli"/>
+        <a:font script="Deva" typeface="Mangal"/>
+        <a:font script="Telu" typeface="Gautami"/>
+        <a:font script="Taml" typeface="Latha"/>
+        <a:font script="Syrc" typeface="Estrangelo Edessa"/>
+        <a:font script="Orya" typeface="Kalinga"/>
+        <a:font script="Mlym" typeface="Kartika"/>
+        <a:font script="Laoo" typeface="DokChampa"/>
+        <a:font script="Sinh" typeface="Iskoola Pota"/>
+        <a:font script="Mong" typeface="Mongolian Baiti"/>
+        <a:font script="Viet" typeface="Arial"/>
+        <a:font script="Uigh" typeface="Microsoft Uighur"/>
+        <a:font script="Geor" typeface="Sylfaen"/>
+        <a:font script="Armn" typeface="Arial"/>
+        <a:font script="Bugi" typeface="Leelawadee UI"/>
+        <a:font script="Bopo" typeface="Microsoft JhengHei"/>
+        <a:font script="Java" typeface="Javanese Text"/>
+        <a:font script="Lisu" typeface="Segoe UI"/>
+        <a:font script="Mymr" typeface="Myanmar Text"/>
+        <a:font script="Nkoo" typeface="Ebrima"/>
+        <a:font script="Olck" typeface="Nirmala UI"/>
+        <a:font script="Osma" typeface="Ebrima"/>
+        <a:font script="Phag" typeface="Phagspa"/>
+        <a:font script="Syrn" typeface="Estrangelo Edessa"/>
+        <a:font script="Syrj" typeface="Estrangelo Edessa"/>
+        <a:font script="Syre" typeface="Estrangelo Edessa"/>
+        <a:font script="Sora" typeface="Nirmala UI"/>
+        <a:font script="Tale" typeface="Microsoft Tai Le"/>
+        <a:font script="Talu" typeface="Microsoft New Tai Lue"/>
+        <a:font script="Tfng" typeface="Ebrima"/>
+      </a:minorFont>
+    </a:fontScheme>
+    <a:fmtScheme name="Office">
+      <a:fillStyleLst>
+        <a:solidFill>
+          <a:schemeClr val="phClr"/>
+        </a:solidFill>
+        <a:gradFill rotWithShape="1">
+          <a:gsLst>
+            <a:gs pos="0">
+              <a:schemeClr val="phClr">
+                <a:lumMod val="110000"/>
+                <a:satMod val="105000"/>
+                <a:tint val="67000"/>
+              </a:schemeClr>
+            </a:gs>
+            <a:gs pos="50000">
+              <a:schemeClr val="phClr">
+                <a:lumMod val="105000"/>
+                <a:satMod val="103000"/>
+                <a:tint val="73000"/>
+              </a:schemeClr>
+            </a:gs>
+            <a:gs pos="100000">
+              <a:schemeClr val="phClr">
+                <a:lumMod val="105000"/>
+                <a:satMod val="109000"/>
+                <a:tint val="81000"/>
+              </a:schemeClr>
+            </a:gs>
+          </a:gsLst>
+          <a:lin ang="5400000" scaled="0"/>
+        </a:gradFill>
+        <a:gradFill rotWithShape="1">
+          <a:gsLst>
+            <a:gs pos="0">
+              <a:schemeClr val="phClr">
+                <a:satMod val="103000"/>
+                <a:lumMod val="102000"/>
+                <a:tint val="94000"/>
+              </a:schemeClr>
+            </a:gs>
+            <a:gs pos="50000">
+              <a:schemeClr val="phClr">
+                <a:satMod val="110000"/>
+                <a:lumMod val="100000"/>
+                <a:shade val="100000"/>
+              </a:schemeClr>
+            </a:gs>
+            <a:gs pos="100000">
+              <a:schemeClr val="phClr">
+                <a:lumMod val="99000"/>
+                <a:satMod val="120000"/>
+                <a:shade val="78000"/>
+              </a:schemeClr>
+            </a:gs>
+          </a:gsLst>
+          <a:lin ang="5400000" scaled="0"/>
+        </a:gradFill>
+      </a:fillStyleLst>
+      <a:lnStyleLst>
+        <a:ln w="6350" cap="flat" cmpd="sng" algn="ctr">
+          <a:solidFill>
+            <a:schemeClr val="phClr"/>
+          </a:solidFill>
+          <a:prstDash val="solid"/>
+          <a:miter lim="800000"/>
+        </a:ln>
+        <a:ln w="12700" cap="flat" cmpd="sng" algn="ctr">
+          <a:solidFill>
+            <a:schemeClr val="phClr"/>
+          </a:solidFill>
+          <a:prstDash val="solid"/>
+          <a:miter lim="800000"/>
+        </a:ln>
+        <a:ln w="19050" cap="flat" cmpd="sng" algn="ctr">
+          <a:solidFill>
+            <a:schemeClr val="phClr"/>
+          </a:solidFill>
+          <a:prstDash val="solid"/>
+          <a:miter lim="800000"/>
+        </a:ln>
+      </a:lnStyleLst>
+      <a:effectStyleLst>
+        <a:effectStyle>
+          <a:effectLst/>
+        </a:effectStyle>
+        <a:effectStyle>
+          <a:effectLst/>
+        </a:effectStyle>
+        <a:effectStyle>
+          <a:effectLst>
+            <a:outerShdw blurRad="57150" dist="19050" dir="5400000" algn="ctr" rotWithShape="0">
+              <a:srgbClr val="000000">
+                <a:alpha val="63000"/>
+              </a:srgbClr>
+            </a:outerShdw>
+          </a:effectLst>
+        </a:effectStyle>
+      </a:effectStyleLst>
+      <a:bgFillStyleLst>
+        <a:solidFill>
+          <a:schemeClr val="phClr"/>
+        </a:solidFill>
+        <a:solidFill>
+          <a:schemeClr val="phClr">
+            <a:tint val="95000"/>
+            <a:satMod val="170000"/>
+          </a:schemeClr>
+        </a:solidFill>
+        <a:gradFill rotWithShape="1">
+          <a:gsLst>
+            <a:gs pos="0">
+              <a:schemeClr val="phClr">
+                <a:tint val="93000"/>
+                <a:satMod val="150000"/>
+                <a:shade val="98000"/>
+                <a:lumMod val="102000"/>
+              </a:schemeClr>
+            </a:gs>
+            <a:gs pos="50000">
+              <a:schemeClr val="phClr">
+                <a:tint val="98000"/>
+                <a:satMod val="130000"/>
+                <a:shade val="90000"/>
+                <a:lumMod val="103000"/>
+              </a:schemeClr>
+            </a:gs>
+            <a:gs pos="100000">
+              <a:schemeClr val="phClr">
+                <a:shade val="63000"/>
+                <a:satMod val="120000"/>
+              </a:schemeClr>
+            </a:gs>
+          </a:gsLst>
+          <a:lin ang="5400000" scaled="0"/>
+        </a:gradFill>
+      </a:bgFillStyleLst>
+    </a:fmtScheme>
+  </a:themeElements>
+  <a:objectDefaults/>
+  <a:extraClrSchemeLst/>
+  <a:extLst>
+    <a:ext uri="{05A4C25C-085E-4340-85A3-A5531E510DB2}">
+      <thm15:themeFamily xmlns:thm15="http://schemas.microsoft.com/office/thememl/2012/main" name="Office Theme" id="{62F939B6-93AF-4DB8-9C6B-D6C7DFDC589F}" vid="{4A3C46E8-61CC-4603-A589-7422A47A8E4A}"/>
+    </a:ext>
+  </a:extLst>
+</a:theme>
 </file>
</xml_diff>